<commit_message>
Solver: failed image aids now show a clean themed placeholder instead of a black slide
Batch 2 wrap-up. On final image-load failure (after 2 retries), swap the
broken <img> for an inline SVG placeholder ("Visual unavailable") that matches
the dark card theme, instead of display:none which left a black slide with a
floating caption. Memory Retention chart empty state was already in place.

Co-Authored-By: Claude Opus 4.8 <noreply@anthropic.com>
</commit_message>
<xml_diff>
--- a/Kairo_Pitch_Deck.pptx
+++ b/Kairo_Pitch_Deck.pptx
@@ -4,6 +4,9 @@
   <p:sldMasterIdLst>
     <p:sldMasterId id="2147483648" r:id="rId1"/>
   </p:sldMasterIdLst>
+  <p:notesMasterIdLst>
+    <p:notesMasterId r:id="rId18"/>
+  </p:notesMasterIdLst>
   <p:sldIdLst>
     <p:sldId id="256" r:id="rId2"/>
     <p:sldId id="257" r:id="rId3"/>
@@ -22,9 +25,6 @@
     <p:sldId id="270" r:id="rId16"/>
     <p:sldId id="271" r:id="rId17"/>
   </p:sldIdLst>
-  <p:notesMasterIdLst>
-    <p:notesMasterId r:id="rId18"/>
-  </p:notesMasterIdLst>
   <p:sldSz cx="12192000" cy="6858000"/>
   <p:notesSz cx="6858000" cy="12192000"/>
   <p:defaultTextStyle>
@@ -119,6 +119,11 @@
       </a:defRPr>
     </a:lvl9pPr>
   </p:defaultTextStyle>
+  <p:extLst>
+    <p:ext uri="{EFAFB233-063F-42B5-8137-9DF3F51BA10A}">
+      <p15:sldGuideLst xmlns:p15="http://schemas.microsoft.com/office/powerpoint/2012/main"/>
+    </p:ext>
+  </p:extLst>
 </p:presentation>
 </file>
 
@@ -144,234 +149,10 @@
           <a:chExt cx="0" cy="0"/>
         </a:xfrm>
       </p:grpSpPr>
-      <p:sp>
-        <p:nvSpPr>
-          <p:cNvPr id="2" name="Header Placeholder 1"/>
-          <p:cNvSpPr>
-            <a:spLocks noGrp="1"/>
-          </p:cNvSpPr>
-          <p:nvPr>
-            <p:ph type="hdr" sz="quarter"/>
-          </p:nvPr>
-        </p:nvSpPr>
-        <p:spPr>
-          <a:xfrm>
-            <a:off x="0" y="0"/>
-            <a:ext cx="2971800" cy="458788"/>
-          </a:xfrm>
-          <a:prstGeom prst="rect">
-            <a:avLst/>
-          </a:prstGeom>
-        </p:spPr>
-        <p:txBody>
-          <a:bodyPr vert="horz" lIns="91440" tIns="45720" rIns="91440" bIns="45720" rtlCol="0"/>
-          <a:lstStyle>
-            <a:lvl1pPr algn="l">
-              <a:defRPr sz="1200"/>
-            </a:lvl1pPr>
-          </a:lstStyle>
-          <a:p>
-            <a:endParaRPr lang="en-US"/>
-          </a:p>
-        </p:txBody>
-      </p:sp>
-      <p:sp>
-        <p:nvSpPr>
-          <p:cNvPr id="3" name="Date Placeholder 2"/>
-          <p:cNvSpPr>
-            <a:spLocks noGrp="1"/>
-          </p:cNvSpPr>
-          <p:nvPr>
-            <p:ph type="dt" idx="1"/>
-          </p:nvPr>
-        </p:nvSpPr>
-        <p:spPr>
-          <a:xfrm>
-            <a:off x="3884613" y="0"/>
-            <a:ext cx="2971800" cy="458788"/>
-          </a:xfrm>
-          <a:prstGeom prst="rect">
-            <a:avLst/>
-          </a:prstGeom>
-        </p:spPr>
-        <p:txBody>
-          <a:bodyPr vert="horz" lIns="91440" tIns="45720" rIns="91440" bIns="45720" rtlCol="0"/>
-          <a:lstStyle>
-            <a:lvl1pPr algn="r">
-              <a:defRPr sz="1200"/>
-            </a:lvl1pPr>
-          </a:lstStyle>
-          <a:p>
-            <a:fld id="{5282F153-3F37-0F45-9E97-73ACFA13230C}" type="datetimeFigureOut">
-              <a:rPr lang="en-US"/>
-              <a:t>7/23/19</a:t>
-            </a:fld>
-            <a:endParaRPr lang="en-US"/>
-          </a:p>
-        </p:txBody>
-      </p:sp>
-      <p:sp>
-        <p:nvSpPr>
-          <p:cNvPr id="4" name="Slide Image Placeholder 3"/>
-          <p:cNvSpPr>
-            <a:spLocks noGrp="1" noRot="1" noChangeAspect="1"/>
-          </p:cNvSpPr>
-          <p:nvPr>
-            <p:ph type="sldImg" idx="2"/>
-          </p:nvPr>
-        </p:nvSpPr>
-        <p:spPr>
-          <a:xfrm>
-            <a:off x="685800" y="1143000"/>
-            <a:ext cx="5486400" cy="3086100"/>
-          </a:xfrm>
-          <a:prstGeom prst="rect">
-            <a:avLst/>
-          </a:prstGeom>
-          <a:noFill/>
-          <a:ln w="12700">
-            <a:solidFill>
-              <a:prstClr val="black"/>
-            </a:solidFill>
-          </a:ln>
-        </p:spPr>
-        <p:txBody>
-          <a:bodyPr vert="horz" lIns="91440" tIns="45720" rIns="91440" bIns="45720" rtlCol="0" anchor="ctr"/>
-          <a:lstStyle/>
-          <a:p>
-            <a:endParaRPr lang="en-US"/>
-          </a:p>
-        </p:txBody>
-      </p:sp>
-      <p:sp>
-        <p:nvSpPr>
-          <p:cNvPr id="5" name="Notes Placeholder 4"/>
-          <p:cNvSpPr>
-            <a:spLocks noGrp="1"/>
-          </p:cNvSpPr>
-          <p:nvPr>
-            <p:ph type="body" sz="quarter" idx="3"/>
-          </p:nvPr>
-        </p:nvSpPr>
-        <p:spPr>
-          <a:xfrm>
-            <a:off x="685800" y="4400550"/>
-            <a:ext cx="5486400" cy="3600450"/>
-          </a:xfrm>
-          <a:prstGeom prst="rect">
-            <a:avLst/>
-          </a:prstGeom>
-        </p:spPr>
-        <p:txBody>
-          <a:bodyPr vert="horz" lIns="91440" tIns="45720" rIns="91440" bIns="45720" rtlCol="0"/>
-          <a:lstStyle/>
-          <a:p>
-            <a:pPr lvl="0"/>
-            <a:r>
-              <a:rPr lang="en-US"/>
-              <a:t>Click to edit Master text styles</a:t>
-            </a:r>
-          </a:p>
-          <a:p>
-            <a:pPr lvl="1"/>
-            <a:r>
-              <a:rPr lang="en-US"/>
-              <a:t>Second level</a:t>
-            </a:r>
-          </a:p>
-          <a:p>
-            <a:pPr lvl="2"/>
-            <a:r>
-              <a:rPr lang="en-US"/>
-              <a:t>Third level</a:t>
-            </a:r>
-          </a:p>
-          <a:p>
-            <a:pPr lvl="3"/>
-            <a:r>
-              <a:rPr lang="en-US"/>
-              <a:t>Fourth level</a:t>
-            </a:r>
-          </a:p>
-          <a:p>
-            <a:pPr lvl="4"/>
-            <a:r>
-              <a:rPr lang="en-US"/>
-              <a:t>Fifth level</a:t>
-            </a:r>
-          </a:p>
-        </p:txBody>
-      </p:sp>
-      <p:sp>
-        <p:nvSpPr>
-          <p:cNvPr id="6" name="Footer Placeholder 5"/>
-          <p:cNvSpPr>
-            <a:spLocks noGrp="1"/>
-          </p:cNvSpPr>
-          <p:nvPr>
-            <p:ph type="ftr" sz="quarter" idx="4"/>
-          </p:nvPr>
-        </p:nvSpPr>
-        <p:spPr>
-          <a:xfrm>
-            <a:off x="0" y="8685213"/>
-            <a:ext cx="2971800" cy="458787"/>
-          </a:xfrm>
-          <a:prstGeom prst="rect">
-            <a:avLst/>
-          </a:prstGeom>
-        </p:spPr>
-        <p:txBody>
-          <a:bodyPr vert="horz" lIns="91440" tIns="45720" rIns="91440" bIns="45720" rtlCol="0" anchor="b"/>
-          <a:lstStyle>
-            <a:lvl1pPr algn="l">
-              <a:defRPr sz="1200"/>
-            </a:lvl1pPr>
-          </a:lstStyle>
-          <a:p>
-            <a:endParaRPr lang="en-US"/>
-          </a:p>
-        </p:txBody>
-      </p:sp>
-      <p:sp>
-        <p:nvSpPr>
-          <p:cNvPr id="7" name="Slide Number Placeholder 6"/>
-          <p:cNvSpPr>
-            <a:spLocks noGrp="1"/>
-          </p:cNvSpPr>
-          <p:nvPr>
-            <p:ph type="sldNum" sz="quarter" idx="5"/>
-          </p:nvPr>
-        </p:nvSpPr>
-        <p:spPr>
-          <a:xfrm>
-            <a:off x="3884613" y="8685213"/>
-            <a:ext cx="2971800" cy="458787"/>
-          </a:xfrm>
-          <a:prstGeom prst="rect">
-            <a:avLst/>
-          </a:prstGeom>
-        </p:spPr>
-        <p:txBody>
-          <a:bodyPr vert="horz" lIns="91440" tIns="45720" rIns="91440" bIns="45720" rtlCol="0" anchor="b"/>
-          <a:lstStyle>
-            <a:lvl1pPr algn="r">
-              <a:defRPr sz="1200"/>
-            </a:lvl1pPr>
-          </a:lstStyle>
-          <a:p>
-            <a:fld id="{CE5E9CC1-C706-0F49-92D6-E571CC5EEA8F}" type="slidenum">
-              <a:rPr lang="en-US"/>
-              <a:t>‹#›</a:t>
-            </a:fld>
-            <a:endParaRPr lang="en-US"/>
-          </a:p>
-        </p:txBody>
-      </p:sp>
     </p:spTree>
     <p:extLst>
       <p:ext uri="{BB962C8B-B14F-4D97-AF65-F5344CB8AC3E}">
-        <p14:creationId xmlns:p14="http://schemas.microsoft.com/office/powerpoint/2010/main" val="1024086991"/>
+        <p14:creationId xmlns:p14="http://schemas.microsoft.com/office/powerpoint/2010/main" val="2127490612"/>
       </p:ext>
     </p:extLst>
   </p:cSld>
@@ -515,10 +296,6 @@
           <a:bodyPr/>
           <a:lstStyle/>
           <a:p>
-            <a:r>
-              <a:rPr lang="en-US" dirty="0"/>
-              <a:t/>
-            </a:r>
             <a:endParaRPr lang="en-US" dirty="0"/>
           </a:p>
         </p:txBody>
@@ -603,10 +380,6 @@
           <a:bodyPr/>
           <a:lstStyle/>
           <a:p>
-            <a:r>
-              <a:rPr lang="en-US" dirty="0"/>
-              <a:t/>
-            </a:r>
             <a:endParaRPr lang="en-US" dirty="0"/>
           </a:p>
         </p:txBody>
@@ -691,10 +464,6 @@
           <a:bodyPr/>
           <a:lstStyle/>
           <a:p>
-            <a:r>
-              <a:rPr lang="en-US" dirty="0"/>
-              <a:t/>
-            </a:r>
             <a:endParaRPr lang="en-US" dirty="0"/>
           </a:p>
         </p:txBody>
@@ -779,10 +548,6 @@
           <a:bodyPr/>
           <a:lstStyle/>
           <a:p>
-            <a:r>
-              <a:rPr lang="en-US" dirty="0"/>
-              <a:t/>
-            </a:r>
             <a:endParaRPr lang="en-US" dirty="0"/>
           </a:p>
         </p:txBody>
@@ -867,10 +632,6 @@
           <a:bodyPr/>
           <a:lstStyle/>
           <a:p>
-            <a:r>
-              <a:rPr lang="en-US" dirty="0"/>
-              <a:t/>
-            </a:r>
             <a:endParaRPr lang="en-US" dirty="0"/>
           </a:p>
         </p:txBody>
@@ -955,10 +716,6 @@
           <a:bodyPr/>
           <a:lstStyle/>
           <a:p>
-            <a:r>
-              <a:rPr lang="en-US" dirty="0"/>
-              <a:t/>
-            </a:r>
             <a:endParaRPr lang="en-US" dirty="0"/>
           </a:p>
         </p:txBody>
@@ -1043,10 +800,6 @@
           <a:bodyPr/>
           <a:lstStyle/>
           <a:p>
-            <a:r>
-              <a:rPr lang="en-US" dirty="0"/>
-              <a:t/>
-            </a:r>
             <a:endParaRPr lang="en-US" dirty="0"/>
           </a:p>
         </p:txBody>
@@ -1131,10 +884,6 @@
           <a:bodyPr/>
           <a:lstStyle/>
           <a:p>
-            <a:r>
-              <a:rPr lang="en-US" dirty="0"/>
-              <a:t/>
-            </a:r>
             <a:endParaRPr lang="en-US" dirty="0"/>
           </a:p>
         </p:txBody>
@@ -1219,10 +968,6 @@
           <a:bodyPr/>
           <a:lstStyle/>
           <a:p>
-            <a:r>
-              <a:rPr lang="en-US" dirty="0"/>
-              <a:t/>
-            </a:r>
             <a:endParaRPr lang="en-US" dirty="0"/>
           </a:p>
         </p:txBody>
@@ -1307,10 +1052,6 @@
           <a:bodyPr/>
           <a:lstStyle/>
           <a:p>
-            <a:r>
-              <a:rPr lang="en-US" dirty="0"/>
-              <a:t/>
-            </a:r>
             <a:endParaRPr lang="en-US" dirty="0"/>
           </a:p>
         </p:txBody>
@@ -1395,10 +1136,6 @@
           <a:bodyPr/>
           <a:lstStyle/>
           <a:p>
-            <a:r>
-              <a:rPr lang="en-US" dirty="0"/>
-              <a:t/>
-            </a:r>
             <a:endParaRPr lang="en-US" dirty="0"/>
           </a:p>
         </p:txBody>
@@ -1483,10 +1220,6 @@
           <a:bodyPr/>
           <a:lstStyle/>
           <a:p>
-            <a:r>
-              <a:rPr lang="en-US" dirty="0"/>
-              <a:t/>
-            </a:r>
             <a:endParaRPr lang="en-US" dirty="0"/>
           </a:p>
         </p:txBody>
@@ -1571,10 +1304,6 @@
           <a:bodyPr/>
           <a:lstStyle/>
           <a:p>
-            <a:r>
-              <a:rPr lang="en-US" dirty="0"/>
-              <a:t/>
-            </a:r>
             <a:endParaRPr lang="en-US" dirty="0"/>
           </a:p>
         </p:txBody>
@@ -1659,10 +1388,6 @@
           <a:bodyPr/>
           <a:lstStyle/>
           <a:p>
-            <a:r>
-              <a:rPr lang="en-US" dirty="0"/>
-              <a:t/>
-            </a:r>
             <a:endParaRPr lang="en-US" dirty="0"/>
           </a:p>
         </p:txBody>
@@ -1747,10 +1472,6 @@
           <a:bodyPr/>
           <a:lstStyle/>
           <a:p>
-            <a:r>
-              <a:rPr lang="en-US" dirty="0"/>
-              <a:t/>
-            </a:r>
             <a:endParaRPr lang="en-US" dirty="0"/>
           </a:p>
         </p:txBody>
@@ -1835,10 +1556,6 @@
           <a:bodyPr/>
           <a:lstStyle/>
           <a:p>
-            <a:r>
-              <a:rPr lang="en-US" dirty="0"/>
-              <a:t/>
-            </a:r>
             <a:endParaRPr lang="en-US" dirty="0"/>
           </a:p>
         </p:txBody>
@@ -1917,6 +1634,7 @@
         <a:solidFill>
           <a:srgbClr val="000000"/>
         </a:solidFill>
+        <a:effectLst/>
       </p:bgPr>
     </p:bg>
     <p:spTree>
@@ -2017,11 +1735,11 @@
           <a:bodyPr wrap="square" rtlCol="0" anchor="ctr"/>
           <a:lstStyle/>
           <a:p>
-            <a:pPr indent="0" marL="0">
-              <a:buNone/>
-            </a:pPr>
-            <a:r>
-              <a:rPr lang="en-US" sz="900" b="1" spc="600" kern="0" dirty="0">
+            <a:pPr marL="0" indent="0">
+              <a:buNone/>
+            </a:pPr>
+            <a:r>
+              <a:rPr lang="en-US" sz="900" b="1" kern="0" spc="600" dirty="0">
                 <a:solidFill>
                   <a:srgbClr val="5A5A5A"/>
                 </a:solidFill>
@@ -2056,11 +1774,11 @@
           <a:bodyPr wrap="square" rtlCol="0" anchor="ctr"/>
           <a:lstStyle/>
           <a:p>
-            <a:pPr algn="r" indent="0" marL="0">
-              <a:buNone/>
-            </a:pPr>
-            <a:r>
-              <a:rPr lang="en-US" sz="900" spc="400" kern="0" dirty="0">
+            <a:pPr marL="0" indent="0" algn="r">
+              <a:buNone/>
+            </a:pPr>
+            <a:r>
+              <a:rPr lang="en-US" sz="900" kern="0" spc="400" dirty="0">
                 <a:solidFill>
                   <a:srgbClr val="5A5A5A"/>
                 </a:solidFill>
@@ -2085,6 +1803,11 @@
 <file path=ppt/slideMasters/slideMaster1.xml><?xml version="1.0" encoding="utf-8"?>
 <p:sldMaster xmlns:a="http://schemas.openxmlformats.org/drawingml/2006/main" xmlns:r="http://schemas.openxmlformats.org/officeDocument/2006/relationships" xmlns:p="http://schemas.openxmlformats.org/presentationml/2006/main">
   <p:cSld>
+    <p:bg>
+      <p:bgRef idx="1001">
+        <a:schemeClr val="bg1"/>
+      </p:bgRef>
+    </p:bg>
     <p:spTree>
       <p:nvGrpSpPr>
         <p:cNvPr id="1" name=""/>
@@ -2398,11 +2121,11 @@
           <a:bodyPr wrap="square" rtlCol="0" anchor="ctr"/>
           <a:lstStyle/>
           <a:p>
-            <a:pPr indent="0" marL="0">
-              <a:buNone/>
-            </a:pPr>
-            <a:r>
-              <a:rPr lang="en-US" sz="11000" b="1" spc="1800" kern="0" dirty="0">
+            <a:pPr marL="0" indent="0">
+              <a:buNone/>
+            </a:pPr>
+            <a:r>
+              <a:rPr lang="en-US" sz="11000" b="1" kern="0" spc="1800" dirty="0">
                 <a:solidFill>
                   <a:srgbClr val="FFFFFF"/>
                 </a:solidFill>
@@ -2437,7 +2160,7 @@
           <a:bodyPr wrap="square" rtlCol="0" anchor="ctr"/>
           <a:lstStyle/>
           <a:p>
-            <a:pPr indent="0" marL="0">
+            <a:pPr marL="0" indent="0">
               <a:buNone/>
             </a:pPr>
             <a:r>
@@ -2499,11 +2222,11 @@
           <a:bodyPr wrap="square" rtlCol="0" anchor="ctr"/>
           <a:lstStyle/>
           <a:p>
-            <a:pPr indent="0" marL="0">
-              <a:buNone/>
-            </a:pPr>
-            <a:r>
-              <a:rPr lang="en-US" sz="1300" spc="300" kern="0" dirty="0">
+            <a:pPr marL="0" indent="0">
+              <a:buNone/>
+            </a:pPr>
+            <a:r>
+              <a:rPr lang="en-US" sz="1300" kern="0" spc="300" dirty="0">
                 <a:solidFill>
                   <a:srgbClr val="7A7A7A"/>
                 </a:solidFill>
@@ -2538,11 +2261,11 @@
           <a:bodyPr wrap="square" rtlCol="0" anchor="ctr"/>
           <a:lstStyle/>
           <a:p>
-            <a:pPr indent="0" marL="0">
-              <a:buNone/>
-            </a:pPr>
-            <a:r>
-              <a:rPr lang="en-US" sz="1100" spc="400" kern="0" dirty="0">
+            <a:pPr marL="0" indent="0">
+              <a:buNone/>
+            </a:pPr>
+            <a:r>
+              <a:rPr lang="en-US" sz="1100" kern="0" spc="400" dirty="0">
                 <a:solidFill>
                   <a:srgbClr val="5A5A5A"/>
                 </a:solidFill>
@@ -2602,11 +2325,11 @@
           <a:bodyPr wrap="square" rtlCol="0" anchor="ctr"/>
           <a:lstStyle/>
           <a:p>
-            <a:pPr indent="0" marL="0">
-              <a:buNone/>
-            </a:pPr>
-            <a:r>
-              <a:rPr lang="en-US" sz="1000" b="1" spc="600" kern="0" dirty="0">
+            <a:pPr marL="0" indent="0">
+              <a:buNone/>
+            </a:pPr>
+            <a:r>
+              <a:rPr lang="en-US" sz="1000" b="1" kern="0" spc="600" dirty="0">
                 <a:solidFill>
                   <a:srgbClr val="7A7A7A"/>
                 </a:solidFill>
@@ -2641,7 +2364,7 @@
           <a:bodyPr wrap="square" rtlCol="0" anchor="t"/>
           <a:lstStyle/>
           <a:p>
-            <a:pPr indent="0" marL="0">
+            <a:pPr marL="0" indent="0">
               <a:buNone/>
             </a:pPr>
             <a:r>
@@ -2658,7 +2381,7 @@
             <a:endParaRPr lang="en-US" sz="4000" dirty="0"/>
           </a:p>
           <a:p>
-            <a:pPr indent="0" marL="0">
+            <a:pPr marL="0" indent="0">
               <a:buNone/>
             </a:pPr>
             <a:r>
@@ -2720,7 +2443,7 @@
           <a:bodyPr wrap="square" rtlCol="0" anchor="ctr"/>
           <a:lstStyle/>
           <a:p>
-            <a:pPr indent="0" marL="0">
+            <a:pPr marL="0" indent="0">
               <a:buNone/>
             </a:pPr>
             <a:r>
@@ -2759,7 +2482,7 @@
           <a:bodyPr wrap="square" rtlCol="0" anchor="ctr"/>
           <a:lstStyle/>
           <a:p>
-            <a:pPr algn="r" indent="0" marL="0">
+            <a:pPr marL="0" indent="0" algn="r">
               <a:buNone/>
             </a:pPr>
             <a:r>
@@ -2821,7 +2544,7 @@
           <a:bodyPr wrap="square" rtlCol="0" anchor="ctr"/>
           <a:lstStyle/>
           <a:p>
-            <a:pPr indent="0" marL="0">
+            <a:pPr marL="0" indent="0">
               <a:buNone/>
             </a:pPr>
             <a:r>
@@ -2860,7 +2583,7 @@
           <a:bodyPr wrap="square" rtlCol="0" anchor="ctr"/>
           <a:lstStyle/>
           <a:p>
-            <a:pPr algn="r" indent="0" marL="0">
+            <a:pPr marL="0" indent="0" algn="r">
               <a:buNone/>
             </a:pPr>
             <a:r>
@@ -2922,7 +2645,7 @@
           <a:bodyPr wrap="square" rtlCol="0" anchor="ctr"/>
           <a:lstStyle/>
           <a:p>
-            <a:pPr indent="0" marL="0">
+            <a:pPr marL="0" indent="0">
               <a:buNone/>
             </a:pPr>
             <a:r>
@@ -2961,7 +2684,7 @@
           <a:bodyPr wrap="square" rtlCol="0" anchor="ctr"/>
           <a:lstStyle/>
           <a:p>
-            <a:pPr algn="r" indent="0" marL="0">
+            <a:pPr marL="0" indent="0" algn="r">
               <a:buNone/>
             </a:pPr>
             <a:r>
@@ -3023,7 +2746,7 @@
           <a:bodyPr wrap="square" rtlCol="0" anchor="ctr"/>
           <a:lstStyle/>
           <a:p>
-            <a:pPr indent="0" marL="0">
+            <a:pPr marL="0" indent="0">
               <a:buNone/>
             </a:pPr>
             <a:r>
@@ -3062,7 +2785,7 @@
           <a:bodyPr wrap="square" rtlCol="0" anchor="ctr"/>
           <a:lstStyle/>
           <a:p>
-            <a:pPr algn="r" indent="0" marL="0">
+            <a:pPr marL="0" indent="0" algn="r">
               <a:buNone/>
             </a:pPr>
             <a:r>
@@ -3124,7 +2847,7 @@
           <a:bodyPr wrap="square" rtlCol="0" anchor="ctr"/>
           <a:lstStyle/>
           <a:p>
-            <a:pPr indent="0" marL="0">
+            <a:pPr marL="0" indent="0">
               <a:buNone/>
             </a:pPr>
             <a:r>
@@ -3163,7 +2886,7 @@
           <a:bodyPr wrap="square" rtlCol="0" anchor="ctr"/>
           <a:lstStyle/>
           <a:p>
-            <a:pPr algn="r" indent="0" marL="0">
+            <a:pPr marL="0" indent="0" algn="r">
               <a:buNone/>
             </a:pPr>
             <a:r>
@@ -3225,7 +2948,7 @@
           <a:bodyPr wrap="square" rtlCol="0" anchor="ctr"/>
           <a:lstStyle/>
           <a:p>
-            <a:pPr indent="0" marL="0">
+            <a:pPr marL="0" indent="0">
               <a:buNone/>
             </a:pPr>
             <a:r>
@@ -3264,7 +2987,7 @@
           <a:bodyPr wrap="square" rtlCol="0" anchor="ctr"/>
           <a:lstStyle/>
           <a:p>
-            <a:pPr algn="r" indent="0" marL="0">
+            <a:pPr marL="0" indent="0" algn="r">
               <a:buNone/>
             </a:pPr>
             <a:r>
@@ -3326,7 +3049,7 @@
           <a:bodyPr wrap="square" rtlCol="0" anchor="ctr"/>
           <a:lstStyle/>
           <a:p>
-            <a:pPr indent="0" marL="0">
+            <a:pPr marL="0" indent="0">
               <a:buNone/>
             </a:pPr>
             <a:r>
@@ -3365,7 +3088,7 @@
           <a:bodyPr wrap="square" rtlCol="0" anchor="ctr"/>
           <a:lstStyle/>
           <a:p>
-            <a:pPr algn="r" indent="0" marL="0">
+            <a:pPr marL="0" indent="0" algn="r">
               <a:buNone/>
             </a:pPr>
             <a:r>
@@ -3427,7 +3150,7 @@
           <a:bodyPr wrap="square" rtlCol="0" anchor="ctr"/>
           <a:lstStyle/>
           <a:p>
-            <a:pPr indent="0" marL="0">
+            <a:pPr marL="0" indent="0">
               <a:buNone/>
             </a:pPr>
             <a:r>
@@ -3466,7 +3189,7 @@
           <a:bodyPr wrap="square" rtlCol="0" anchor="ctr"/>
           <a:lstStyle/>
           <a:p>
-            <a:pPr algn="r" indent="0" marL="0">
+            <a:pPr marL="0" indent="0" algn="r">
               <a:buNone/>
             </a:pPr>
             <a:r>
@@ -3530,11 +3253,11 @@
           <a:bodyPr wrap="square" rtlCol="0" anchor="ctr"/>
           <a:lstStyle/>
           <a:p>
-            <a:pPr indent="0" marL="0">
-              <a:buNone/>
-            </a:pPr>
-            <a:r>
-              <a:rPr lang="en-US" sz="1000" b="1" spc="600" kern="0" dirty="0">
+            <a:pPr marL="0" indent="0">
+              <a:buNone/>
+            </a:pPr>
+            <a:r>
+              <a:rPr lang="en-US" sz="1000" b="1" kern="0" spc="600" dirty="0">
                 <a:solidFill>
                   <a:srgbClr val="7A7A7A"/>
                 </a:solidFill>
@@ -3569,7 +3292,7 @@
           <a:bodyPr wrap="square" rtlCol="0" anchor="t"/>
           <a:lstStyle/>
           <a:p>
-            <a:pPr indent="0" marL="0">
+            <a:pPr marL="0" indent="0">
               <a:buNone/>
             </a:pPr>
             <a:r>
@@ -3586,7 +3309,7 @@
             <a:endParaRPr lang="en-US" sz="4000" dirty="0"/>
           </a:p>
           <a:p>
-            <a:pPr indent="0" marL="0">
+            <a:pPr marL="0" indent="0">
               <a:buNone/>
             </a:pPr>
             <a:r>
@@ -3648,7 +3371,7 @@
           <a:bodyPr wrap="square" rtlCol="0" anchor="ctr"/>
           <a:lstStyle/>
           <a:p>
-            <a:pPr indent="0" marL="0">
+            <a:pPr marL="0" indent="0">
               <a:buNone/>
             </a:pPr>
             <a:r>
@@ -3687,7 +3410,7 @@
           <a:bodyPr wrap="square" rtlCol="0" anchor="ctr"/>
           <a:lstStyle/>
           <a:p>
-            <a:pPr indent="0" marL="0">
+            <a:pPr marL="0" indent="0">
               <a:buNone/>
             </a:pPr>
             <a:r>
@@ -3749,7 +3472,7 @@
           <a:bodyPr wrap="square" rtlCol="0" anchor="ctr"/>
           <a:lstStyle/>
           <a:p>
-            <a:pPr indent="0" marL="0">
+            <a:pPr marL="0" indent="0">
               <a:buNone/>
             </a:pPr>
             <a:r>
@@ -3788,7 +3511,7 @@
           <a:bodyPr wrap="square" rtlCol="0" anchor="ctr"/>
           <a:lstStyle/>
           <a:p>
-            <a:pPr indent="0" marL="0">
+            <a:pPr marL="0" indent="0">
               <a:buNone/>
             </a:pPr>
             <a:r>
@@ -3850,7 +3573,7 @@
           <a:bodyPr wrap="square" rtlCol="0" anchor="ctr"/>
           <a:lstStyle/>
           <a:p>
-            <a:pPr indent="0" marL="0">
+            <a:pPr marL="0" indent="0">
               <a:buNone/>
             </a:pPr>
             <a:r>
@@ -3889,7 +3612,7 @@
           <a:bodyPr wrap="square" rtlCol="0" anchor="ctr"/>
           <a:lstStyle/>
           <a:p>
-            <a:pPr indent="0" marL="0">
+            <a:pPr marL="0" indent="0">
               <a:buNone/>
             </a:pPr>
             <a:r>
@@ -3951,7 +3674,7 @@
           <a:bodyPr wrap="square" rtlCol="0" anchor="ctr"/>
           <a:lstStyle/>
           <a:p>
-            <a:pPr indent="0" marL="0">
+            <a:pPr marL="0" indent="0">
               <a:buNone/>
             </a:pPr>
             <a:r>
@@ -3990,7 +3713,7 @@
           <a:bodyPr wrap="square" rtlCol="0" anchor="ctr"/>
           <a:lstStyle/>
           <a:p>
-            <a:pPr indent="0" marL="0">
+            <a:pPr marL="0" indent="0">
               <a:buNone/>
             </a:pPr>
             <a:r>
@@ -4052,7 +3775,7 @@
           <a:bodyPr wrap="square" rtlCol="0" anchor="ctr"/>
           <a:lstStyle/>
           <a:p>
-            <a:pPr indent="0" marL="0">
+            <a:pPr marL="0" indent="0">
               <a:buNone/>
             </a:pPr>
             <a:r>
@@ -4091,7 +3814,7 @@
           <a:bodyPr wrap="square" rtlCol="0" anchor="ctr"/>
           <a:lstStyle/>
           <a:p>
-            <a:pPr indent="0" marL="0">
+            <a:pPr marL="0" indent="0">
               <a:buNone/>
             </a:pPr>
             <a:r>
@@ -4153,7 +3876,7 @@
           <a:bodyPr wrap="square" rtlCol="0" anchor="ctr"/>
           <a:lstStyle/>
           <a:p>
-            <a:pPr indent="0" marL="0">
+            <a:pPr marL="0" indent="0">
               <a:buNone/>
             </a:pPr>
             <a:r>
@@ -4192,7 +3915,7 @@
           <a:bodyPr wrap="square" rtlCol="0" anchor="ctr"/>
           <a:lstStyle/>
           <a:p>
-            <a:pPr indent="0" marL="0">
+            <a:pPr marL="0" indent="0">
               <a:buNone/>
             </a:pPr>
             <a:r>
@@ -4256,11 +3979,11 @@
           <a:bodyPr wrap="square" rtlCol="0" anchor="ctr"/>
           <a:lstStyle/>
           <a:p>
-            <a:pPr indent="0" marL="0">
-              <a:buNone/>
-            </a:pPr>
-            <a:r>
-              <a:rPr lang="en-US" sz="1000" b="1" spc="600" kern="0" dirty="0">
+            <a:pPr marL="0" indent="0">
+              <a:buNone/>
+            </a:pPr>
+            <a:r>
+              <a:rPr lang="en-US" sz="1000" b="1" kern="0" spc="600" dirty="0">
                 <a:solidFill>
                   <a:srgbClr val="7A7A7A"/>
                 </a:solidFill>
@@ -4295,7 +4018,7 @@
           <a:bodyPr wrap="square" rtlCol="0" anchor="t"/>
           <a:lstStyle/>
           <a:p>
-            <a:pPr indent="0" marL="0">
+            <a:pPr marL="0" indent="0">
               <a:buNone/>
             </a:pPr>
             <a:r>
@@ -4312,7 +4035,7 @@
             <a:endParaRPr lang="en-US" sz="4000" dirty="0"/>
           </a:p>
           <a:p>
-            <a:pPr indent="0" marL="0">
+            <a:pPr marL="0" indent="0">
               <a:buNone/>
             </a:pPr>
             <a:r>
@@ -4378,11 +4101,11 @@
           <a:bodyPr wrap="square" rtlCol="0" anchor="ctr"/>
           <a:lstStyle/>
           <a:p>
-            <a:pPr indent="0" marL="0">
-              <a:buNone/>
-            </a:pPr>
-            <a:r>
-              <a:rPr lang="en-US" sz="1000" b="1" spc="500" kern="0" dirty="0">
+            <a:pPr marL="0" indent="0">
+              <a:buNone/>
+            </a:pPr>
+            <a:r>
+              <a:rPr lang="en-US" sz="1000" b="1" kern="0" spc="500" dirty="0">
                 <a:solidFill>
                   <a:srgbClr val="999999"/>
                 </a:solidFill>
@@ -4550,11 +4273,11 @@
           <a:bodyPr wrap="square" rtlCol="0" anchor="ctr"/>
           <a:lstStyle/>
           <a:p>
-            <a:pPr indent="0" marL="0">
-              <a:buNone/>
-            </a:pPr>
-            <a:r>
-              <a:rPr lang="en-US" sz="1000" b="1" spc="500" kern="0" dirty="0">
+            <a:pPr marL="0" indent="0">
+              <a:buNone/>
+            </a:pPr>
+            <a:r>
+              <a:rPr lang="en-US" sz="1000" b="1" kern="0" spc="500" dirty="0">
                 <a:solidFill>
                   <a:srgbClr val="7A7A7A"/>
                 </a:solidFill>
@@ -4695,7 +4418,7 @@
           <a:bodyPr wrap="square" rtlCol="0" anchor="ctr"/>
           <a:lstStyle/>
           <a:p>
-            <a:pPr indent="0" marL="0">
+            <a:pPr marL="0" indent="0">
               <a:buNone/>
             </a:pPr>
             <a:r>
@@ -4759,11 +4482,11 @@
           <a:bodyPr wrap="square" rtlCol="0" anchor="ctr"/>
           <a:lstStyle/>
           <a:p>
-            <a:pPr indent="0" marL="0">
-              <a:buNone/>
-            </a:pPr>
-            <a:r>
-              <a:rPr lang="en-US" sz="1000" b="1" spc="600" kern="0" dirty="0">
+            <a:pPr marL="0" indent="0">
+              <a:buNone/>
+            </a:pPr>
+            <a:r>
+              <a:rPr lang="en-US" sz="1000" b="1" kern="0" spc="600" dirty="0">
                 <a:solidFill>
                   <a:srgbClr val="7A7A7A"/>
                 </a:solidFill>
@@ -4798,7 +4521,7 @@
           <a:bodyPr wrap="square" rtlCol="0" anchor="t"/>
           <a:lstStyle/>
           <a:p>
-            <a:pPr indent="0" marL="0">
+            <a:pPr marL="0" indent="0">
               <a:buNone/>
             </a:pPr>
             <a:r>
@@ -4815,7 +4538,7 @@
             <a:endParaRPr lang="en-US" sz="4000" dirty="0"/>
           </a:p>
           <a:p>
-            <a:pPr indent="0" marL="0">
+            <a:pPr marL="0" indent="0">
               <a:buNone/>
             </a:pPr>
             <a:r>
@@ -4877,11 +4600,11 @@
           <a:bodyPr wrap="square" rtlCol="0" anchor="ctr"/>
           <a:lstStyle/>
           <a:p>
-            <a:pPr indent="0" marL="0">
-              <a:buNone/>
-            </a:pPr>
-            <a:r>
-              <a:rPr lang="en-US" sz="1200" b="1" spc="400" kern="0" dirty="0">
+            <a:pPr marL="0" indent="0">
+              <a:buNone/>
+            </a:pPr>
+            <a:r>
+              <a:rPr lang="en-US" sz="1200" b="1" kern="0" spc="400" dirty="0">
                 <a:solidFill>
                   <a:srgbClr val="7A7A7A"/>
                 </a:solidFill>
@@ -4916,7 +4639,7 @@
           <a:bodyPr wrap="square" rtlCol="0" anchor="ctr"/>
           <a:lstStyle/>
           <a:p>
-            <a:pPr indent="0" marL="0">
+            <a:pPr marL="0" indent="0">
               <a:buNone/>
             </a:pPr>
             <a:r>
@@ -4978,11 +4701,11 @@
           <a:bodyPr wrap="square" rtlCol="0" anchor="ctr"/>
           <a:lstStyle/>
           <a:p>
-            <a:pPr indent="0" marL="0">
-              <a:buNone/>
-            </a:pPr>
-            <a:r>
-              <a:rPr lang="en-US" sz="1200" b="1" spc="400" kern="0" dirty="0">
+            <a:pPr marL="0" indent="0">
+              <a:buNone/>
+            </a:pPr>
+            <a:r>
+              <a:rPr lang="en-US" sz="1200" b="1" kern="0" spc="400" dirty="0">
                 <a:solidFill>
                   <a:srgbClr val="7A7A7A"/>
                 </a:solidFill>
@@ -5017,7 +4740,7 @@
           <a:bodyPr wrap="square" rtlCol="0" anchor="ctr"/>
           <a:lstStyle/>
           <a:p>
-            <a:pPr indent="0" marL="0">
+            <a:pPr marL="0" indent="0">
               <a:buNone/>
             </a:pPr>
             <a:r>
@@ -5079,11 +4802,11 @@
           <a:bodyPr wrap="square" rtlCol="0" anchor="ctr"/>
           <a:lstStyle/>
           <a:p>
-            <a:pPr indent="0" marL="0">
-              <a:buNone/>
-            </a:pPr>
-            <a:r>
-              <a:rPr lang="en-US" sz="1200" b="1" spc="400" kern="0" dirty="0">
+            <a:pPr marL="0" indent="0">
+              <a:buNone/>
+            </a:pPr>
+            <a:r>
+              <a:rPr lang="en-US" sz="1200" b="1" kern="0" spc="400" dirty="0">
                 <a:solidFill>
                   <a:srgbClr val="7A7A7A"/>
                 </a:solidFill>
@@ -5118,7 +4841,7 @@
           <a:bodyPr wrap="square" rtlCol="0" anchor="ctr"/>
           <a:lstStyle/>
           <a:p>
-            <a:pPr indent="0" marL="0">
+            <a:pPr marL="0" indent="0">
               <a:buNone/>
             </a:pPr>
             <a:r>
@@ -5180,11 +4903,11 @@
           <a:bodyPr wrap="square" rtlCol="0" anchor="ctr"/>
           <a:lstStyle/>
           <a:p>
-            <a:pPr indent="0" marL="0">
-              <a:buNone/>
-            </a:pPr>
-            <a:r>
-              <a:rPr lang="en-US" sz="1200" b="1" spc="400" kern="0" dirty="0">
+            <a:pPr marL="0" indent="0">
+              <a:buNone/>
+            </a:pPr>
+            <a:r>
+              <a:rPr lang="en-US" sz="1200" b="1" kern="0" spc="400" dirty="0">
                 <a:solidFill>
                   <a:srgbClr val="7A7A7A"/>
                 </a:solidFill>
@@ -5219,7 +4942,7 @@
           <a:bodyPr wrap="square" rtlCol="0" anchor="ctr"/>
           <a:lstStyle/>
           <a:p>
-            <a:pPr indent="0" marL="0">
+            <a:pPr marL="0" indent="0">
               <a:buNone/>
             </a:pPr>
             <a:r>
@@ -5281,11 +5004,11 @@
           <a:bodyPr wrap="square" rtlCol="0" anchor="ctr"/>
           <a:lstStyle/>
           <a:p>
-            <a:pPr indent="0" marL="0">
-              <a:buNone/>
-            </a:pPr>
-            <a:r>
-              <a:rPr lang="en-US" sz="1200" b="1" spc="400" kern="0" dirty="0">
+            <a:pPr marL="0" indent="0">
+              <a:buNone/>
+            </a:pPr>
+            <a:r>
+              <a:rPr lang="en-US" sz="1200" b="1" kern="0" spc="400" dirty="0">
                 <a:solidFill>
                   <a:srgbClr val="7A7A7A"/>
                 </a:solidFill>
@@ -5320,7 +5043,7 @@
           <a:bodyPr wrap="square" rtlCol="0" anchor="ctr"/>
           <a:lstStyle/>
           <a:p>
-            <a:pPr indent="0" marL="0">
+            <a:pPr marL="0" indent="0">
               <a:buNone/>
             </a:pPr>
             <a:r>
@@ -5382,11 +5105,11 @@
           <a:bodyPr wrap="square" rtlCol="0" anchor="ctr"/>
           <a:lstStyle/>
           <a:p>
-            <a:pPr indent="0" marL="0">
-              <a:buNone/>
-            </a:pPr>
-            <a:r>
-              <a:rPr lang="en-US" sz="1200" b="1" spc="400" kern="0" dirty="0">
+            <a:pPr marL="0" indent="0">
+              <a:buNone/>
+            </a:pPr>
+            <a:r>
+              <a:rPr lang="en-US" sz="1200" b="1" kern="0" spc="400" dirty="0">
                 <a:solidFill>
                   <a:srgbClr val="7A7A7A"/>
                 </a:solidFill>
@@ -5421,7 +5144,7 @@
           <a:bodyPr wrap="square" rtlCol="0" anchor="ctr"/>
           <a:lstStyle/>
           <a:p>
-            <a:pPr indent="0" marL="0">
+            <a:pPr marL="0" indent="0">
               <a:buNone/>
             </a:pPr>
             <a:r>
@@ -5483,11 +5206,11 @@
           <a:bodyPr wrap="square" rtlCol="0" anchor="ctr"/>
           <a:lstStyle/>
           <a:p>
-            <a:pPr indent="0" marL="0">
-              <a:buNone/>
-            </a:pPr>
-            <a:r>
-              <a:rPr lang="en-US" sz="1200" b="1" spc="400" kern="0" dirty="0">
+            <a:pPr marL="0" indent="0">
+              <a:buNone/>
+            </a:pPr>
+            <a:r>
+              <a:rPr lang="en-US" sz="1200" b="1" kern="0" spc="400" dirty="0">
                 <a:solidFill>
                   <a:srgbClr val="7A7A7A"/>
                 </a:solidFill>
@@ -5522,7 +5245,7 @@
           <a:bodyPr wrap="square" rtlCol="0" anchor="ctr"/>
           <a:lstStyle/>
           <a:p>
-            <a:pPr indent="0" marL="0">
+            <a:pPr marL="0" indent="0">
               <a:buNone/>
             </a:pPr>
             <a:r>
@@ -5586,11 +5309,11 @@
           <a:bodyPr wrap="square" rtlCol="0" anchor="ctr"/>
           <a:lstStyle/>
           <a:p>
-            <a:pPr indent="0" marL="0">
-              <a:buNone/>
-            </a:pPr>
-            <a:r>
-              <a:rPr lang="en-US" sz="1000" b="1" spc="600" kern="0" dirty="0">
+            <a:pPr marL="0" indent="0">
+              <a:buNone/>
+            </a:pPr>
+            <a:r>
+              <a:rPr lang="en-US" sz="1000" b="1" kern="0" spc="600" dirty="0">
                 <a:solidFill>
                   <a:srgbClr val="7A7A7A"/>
                 </a:solidFill>
@@ -5625,7 +5348,7 @@
           <a:bodyPr wrap="square" rtlCol="0" anchor="t"/>
           <a:lstStyle/>
           <a:p>
-            <a:pPr indent="0" marL="0">
+            <a:pPr marL="0" indent="0">
               <a:buNone/>
             </a:pPr>
             <a:r>
@@ -5642,7 +5365,7 @@
             <a:endParaRPr lang="en-US" sz="4000" dirty="0"/>
           </a:p>
           <a:p>
-            <a:pPr indent="0" marL="0">
+            <a:pPr marL="0" indent="0">
               <a:buNone/>
             </a:pPr>
             <a:r>
@@ -5704,7 +5427,7 @@
           <a:bodyPr wrap="square" rtlCol="0" anchor="ctr"/>
           <a:lstStyle/>
           <a:p>
-            <a:pPr indent="0" marL="0">
+            <a:pPr marL="0" indent="0">
               <a:buNone/>
             </a:pPr>
             <a:r>
@@ -5743,7 +5466,7 @@
           <a:bodyPr wrap="square" rtlCol="0" anchor="ctr"/>
           <a:lstStyle/>
           <a:p>
-            <a:pPr indent="0" marL="0">
+            <a:pPr marL="0" indent="0">
               <a:buNone/>
             </a:pPr>
             <a:r>
@@ -5805,7 +5528,7 @@
           <a:bodyPr wrap="square" rtlCol="0" anchor="ctr"/>
           <a:lstStyle/>
           <a:p>
-            <a:pPr indent="0" marL="0">
+            <a:pPr marL="0" indent="0">
               <a:buNone/>
             </a:pPr>
             <a:r>
@@ -5844,7 +5567,7 @@
           <a:bodyPr wrap="square" rtlCol="0" anchor="ctr"/>
           <a:lstStyle/>
           <a:p>
-            <a:pPr indent="0" marL="0">
+            <a:pPr marL="0" indent="0">
               <a:buNone/>
             </a:pPr>
             <a:r>
@@ -5906,7 +5629,7 @@
           <a:bodyPr wrap="square" rtlCol="0" anchor="ctr"/>
           <a:lstStyle/>
           <a:p>
-            <a:pPr indent="0" marL="0">
+            <a:pPr marL="0" indent="0">
               <a:buNone/>
             </a:pPr>
             <a:r>
@@ -5945,7 +5668,7 @@
           <a:bodyPr wrap="square" rtlCol="0" anchor="ctr"/>
           <a:lstStyle/>
           <a:p>
-            <a:pPr indent="0" marL="0">
+            <a:pPr marL="0" indent="0">
               <a:buNone/>
             </a:pPr>
             <a:r>
@@ -6007,7 +5730,7 @@
           <a:bodyPr wrap="square" rtlCol="0" anchor="ctr"/>
           <a:lstStyle/>
           <a:p>
-            <a:pPr indent="0" marL="0">
+            <a:pPr marL="0" indent="0">
               <a:buNone/>
             </a:pPr>
             <a:r>
@@ -6046,7 +5769,7 @@
           <a:bodyPr wrap="square" rtlCol="0" anchor="ctr"/>
           <a:lstStyle/>
           <a:p>
-            <a:pPr indent="0" marL="0">
+            <a:pPr marL="0" indent="0">
               <a:buNone/>
             </a:pPr>
             <a:r>
@@ -6108,7 +5831,7 @@
           <a:bodyPr wrap="square" rtlCol="0" anchor="ctr"/>
           <a:lstStyle/>
           <a:p>
-            <a:pPr indent="0" marL="0">
+            <a:pPr marL="0" indent="0">
               <a:buNone/>
             </a:pPr>
             <a:r>
@@ -6147,7 +5870,7 @@
           <a:bodyPr wrap="square" rtlCol="0" anchor="ctr"/>
           <a:lstStyle/>
           <a:p>
-            <a:pPr indent="0" marL="0">
+            <a:pPr marL="0" indent="0">
               <a:buNone/>
             </a:pPr>
             <a:r>
@@ -6211,11 +5934,11 @@
           <a:bodyPr wrap="square" rtlCol="0" anchor="ctr"/>
           <a:lstStyle/>
           <a:p>
-            <a:pPr indent="0" marL="0">
-              <a:buNone/>
-            </a:pPr>
-            <a:r>
-              <a:rPr lang="en-US" sz="1000" b="1" spc="600" kern="0" dirty="0">
+            <a:pPr marL="0" indent="0">
+              <a:buNone/>
+            </a:pPr>
+            <a:r>
+              <a:rPr lang="en-US" sz="1000" b="1" kern="0" spc="600" dirty="0">
                 <a:solidFill>
                   <a:srgbClr val="7A7A7A"/>
                 </a:solidFill>
@@ -6250,7 +5973,7 @@
           <a:bodyPr wrap="square" rtlCol="0" anchor="t"/>
           <a:lstStyle/>
           <a:p>
-            <a:pPr indent="0" marL="0">
+            <a:pPr marL="0" indent="0">
               <a:buNone/>
             </a:pPr>
             <a:r>
@@ -6312,11 +6035,11 @@
           <a:bodyPr wrap="square" rtlCol="0" anchor="ctr"/>
           <a:lstStyle/>
           <a:p>
-            <a:pPr indent="0" marL="0">
-              <a:buNone/>
-            </a:pPr>
-            <a:r>
-              <a:rPr lang="en-US" sz="1200" b="1" spc="400" kern="0" dirty="0">
+            <a:pPr marL="0" indent="0">
+              <a:buNone/>
+            </a:pPr>
+            <a:r>
+              <a:rPr lang="en-US" sz="1200" b="1" kern="0" spc="400" dirty="0">
                 <a:solidFill>
                   <a:srgbClr val="7A7A7A"/>
                 </a:solidFill>
@@ -6351,7 +6074,7 @@
           <a:bodyPr wrap="square" rtlCol="0" anchor="ctr"/>
           <a:lstStyle/>
           <a:p>
-            <a:pPr indent="0" marL="0">
+            <a:pPr marL="0" indent="0">
               <a:buNone/>
             </a:pPr>
             <a:r>
@@ -6413,11 +6136,11 @@
           <a:bodyPr wrap="square" rtlCol="0" anchor="ctr"/>
           <a:lstStyle/>
           <a:p>
-            <a:pPr indent="0" marL="0">
-              <a:buNone/>
-            </a:pPr>
-            <a:r>
-              <a:rPr lang="en-US" sz="1200" b="1" spc="400" kern="0" dirty="0">
+            <a:pPr marL="0" indent="0">
+              <a:buNone/>
+            </a:pPr>
+            <a:r>
+              <a:rPr lang="en-US" sz="1200" b="1" kern="0" spc="400" dirty="0">
                 <a:solidFill>
                   <a:srgbClr val="7A7A7A"/>
                 </a:solidFill>
@@ -6452,7 +6175,7 @@
           <a:bodyPr wrap="square" rtlCol="0" anchor="ctr"/>
           <a:lstStyle/>
           <a:p>
-            <a:pPr indent="0" marL="0">
+            <a:pPr marL="0" indent="0">
               <a:buNone/>
             </a:pPr>
             <a:r>
@@ -6514,11 +6237,11 @@
           <a:bodyPr wrap="square" rtlCol="0" anchor="ctr"/>
           <a:lstStyle/>
           <a:p>
-            <a:pPr indent="0" marL="0">
-              <a:buNone/>
-            </a:pPr>
-            <a:r>
-              <a:rPr lang="en-US" sz="1200" b="1" spc="400" kern="0" dirty="0">
+            <a:pPr marL="0" indent="0">
+              <a:buNone/>
+            </a:pPr>
+            <a:r>
+              <a:rPr lang="en-US" sz="1200" b="1" kern="0" spc="400" dirty="0">
                 <a:solidFill>
                   <a:srgbClr val="7A7A7A"/>
                 </a:solidFill>
@@ -6553,7 +6276,7 @@
           <a:bodyPr wrap="square" rtlCol="0" anchor="ctr"/>
           <a:lstStyle/>
           <a:p>
-            <a:pPr indent="0" marL="0">
+            <a:pPr marL="0" indent="0">
               <a:buNone/>
             </a:pPr>
             <a:r>
@@ -6615,11 +6338,11 @@
           <a:bodyPr wrap="square" rtlCol="0" anchor="ctr"/>
           <a:lstStyle/>
           <a:p>
-            <a:pPr indent="0" marL="0">
-              <a:buNone/>
-            </a:pPr>
-            <a:r>
-              <a:rPr lang="en-US" sz="1200" b="1" spc="400" kern="0" dirty="0">
+            <a:pPr marL="0" indent="0">
+              <a:buNone/>
+            </a:pPr>
+            <a:r>
+              <a:rPr lang="en-US" sz="1200" b="1" kern="0" spc="400" dirty="0">
                 <a:solidFill>
                   <a:srgbClr val="7A7A7A"/>
                 </a:solidFill>
@@ -6654,7 +6377,7 @@
           <a:bodyPr wrap="square" rtlCol="0" anchor="ctr"/>
           <a:lstStyle/>
           <a:p>
-            <a:pPr indent="0" marL="0">
+            <a:pPr marL="0" indent="0">
               <a:buNone/>
             </a:pPr>
             <a:r>
@@ -6716,11 +6439,11 @@
           <a:bodyPr wrap="square" rtlCol="0" anchor="ctr"/>
           <a:lstStyle/>
           <a:p>
-            <a:pPr indent="0" marL="0">
-              <a:buNone/>
-            </a:pPr>
-            <a:r>
-              <a:rPr lang="en-US" sz="1200" b="1" spc="400" kern="0" dirty="0">
+            <a:pPr marL="0" indent="0">
+              <a:buNone/>
+            </a:pPr>
+            <a:r>
+              <a:rPr lang="en-US" sz="1200" b="1" kern="0" spc="400" dirty="0">
                 <a:solidFill>
                   <a:srgbClr val="7A7A7A"/>
                 </a:solidFill>
@@ -6755,7 +6478,7 @@
           <a:bodyPr wrap="square" rtlCol="0" anchor="ctr"/>
           <a:lstStyle/>
           <a:p>
-            <a:pPr indent="0" marL="0">
+            <a:pPr marL="0" indent="0">
               <a:buNone/>
             </a:pPr>
             <a:r>
@@ -6817,11 +6540,11 @@
           <a:bodyPr wrap="square" rtlCol="0" anchor="ctr"/>
           <a:lstStyle/>
           <a:p>
-            <a:pPr indent="0" marL="0">
-              <a:buNone/>
-            </a:pPr>
-            <a:r>
-              <a:rPr lang="en-US" sz="1200" b="1" spc="400" kern="0" dirty="0">
+            <a:pPr marL="0" indent="0">
+              <a:buNone/>
+            </a:pPr>
+            <a:r>
+              <a:rPr lang="en-US" sz="1200" b="1" kern="0" spc="400" dirty="0">
                 <a:solidFill>
                   <a:srgbClr val="7A7A7A"/>
                 </a:solidFill>
@@ -6856,7 +6579,7 @@
           <a:bodyPr wrap="square" rtlCol="0" anchor="ctr"/>
           <a:lstStyle/>
           <a:p>
-            <a:pPr indent="0" marL="0">
+            <a:pPr marL="0" indent="0">
               <a:buNone/>
             </a:pPr>
             <a:r>
@@ -6920,11 +6643,11 @@
           <a:bodyPr wrap="square" rtlCol="0" anchor="ctr"/>
           <a:lstStyle/>
           <a:p>
-            <a:pPr indent="0" marL="0">
-              <a:buNone/>
-            </a:pPr>
-            <a:r>
-              <a:rPr lang="en-US" sz="1000" b="1" spc="600" kern="0" dirty="0">
+            <a:pPr marL="0" indent="0">
+              <a:buNone/>
+            </a:pPr>
+            <a:r>
+              <a:rPr lang="en-US" sz="1000" b="1" kern="0" spc="600" dirty="0">
                 <a:solidFill>
                   <a:srgbClr val="7A7A7A"/>
                 </a:solidFill>
@@ -6946,7 +6669,7 @@
         </p:nvSpPr>
         <p:spPr>
           <a:xfrm>
-            <a:off x="548640" y="914400"/>
+            <a:off x="594360" y="845821"/>
             <a:ext cx="10972800" cy="2377440"/>
           </a:xfrm>
           <a:prstGeom prst="rect">
@@ -6959,9 +6682,6 @@
           <a:bodyPr wrap="square" rtlCol="0" anchor="t"/>
           <a:lstStyle/>
           <a:p>
-            <a:pPr indent="0" marL="0">
-              <a:buNone/>
-            </a:pPr>
             <a:r>
               <a:rPr lang="en-US" sz="5800" b="1" dirty="0">
                 <a:solidFill>
@@ -6976,9 +6696,6 @@
             <a:endParaRPr lang="en-US" sz="5800" dirty="0"/>
           </a:p>
           <a:p>
-            <a:pPr indent="0" marL="0">
-              <a:buNone/>
-            </a:pPr>
             <a:r>
               <a:rPr lang="en-US" sz="5800" b="1" dirty="0">
                 <a:solidFill>
@@ -6993,9 +6710,6 @@
             <a:endParaRPr lang="en-US" sz="5800" dirty="0"/>
           </a:p>
           <a:p>
-            <a:pPr indent="0" marL="0">
-              <a:buNone/>
-            </a:pPr>
             <a:r>
               <a:rPr lang="en-US" sz="5800" b="1" dirty="0">
                 <a:solidFill>
@@ -7005,7 +6719,7 @@
                 <a:ea typeface="Calibri" pitchFamily="34" charset="-122"/>
                 <a:cs typeface="Calibri" pitchFamily="34" charset="-120"/>
               </a:rPr>
-              <a:t>students.</a:t>
+              <a:t>students. </a:t>
             </a:r>
             <a:endParaRPr lang="en-US" sz="5800" dirty="0"/>
           </a:p>
@@ -7055,11 +6769,11 @@
           <a:bodyPr wrap="square" rtlCol="0" anchor="ctr"/>
           <a:lstStyle/>
           <a:p>
-            <a:pPr indent="0" marL="0">
-              <a:buNone/>
-            </a:pPr>
-            <a:r>
-              <a:rPr lang="en-US" sz="1200" b="1" spc="500" kern="0" dirty="0">
+            <a:pPr marL="0" indent="0">
+              <a:buNone/>
+            </a:pPr>
+            <a:r>
+              <a:rPr lang="en-US" sz="1200" b="1" kern="0" spc="500" dirty="0">
                 <a:solidFill>
                   <a:srgbClr val="7A7A7A"/>
                 </a:solidFill>
@@ -7081,7 +6795,7 @@
         </p:nvSpPr>
         <p:spPr>
           <a:xfrm>
-            <a:off x="4297680" y="4023360"/>
+            <a:off x="4328162" y="4069080"/>
             <a:ext cx="7315200" cy="365760"/>
           </a:xfrm>
           <a:prstGeom prst="rect">
@@ -7094,7 +6808,7 @@
           <a:bodyPr wrap="square" rtlCol="0" anchor="ctr"/>
           <a:lstStyle/>
           <a:p>
-            <a:pPr indent="0" marL="0">
+            <a:pPr marL="0" indent="0">
               <a:buNone/>
             </a:pPr>
             <a:r>
@@ -7156,11 +6870,11 @@
           <a:bodyPr wrap="square" rtlCol="0" anchor="ctr"/>
           <a:lstStyle/>
           <a:p>
-            <a:pPr indent="0" marL="0">
-              <a:buNone/>
-            </a:pPr>
-            <a:r>
-              <a:rPr lang="en-US" sz="1200" b="1" spc="500" kern="0" dirty="0">
+            <a:pPr marL="0" indent="0">
+              <a:buNone/>
+            </a:pPr>
+            <a:r>
+              <a:rPr lang="en-US" sz="1200" b="1" kern="0" spc="500" dirty="0">
                 <a:solidFill>
                   <a:srgbClr val="7A7A7A"/>
                 </a:solidFill>
@@ -7195,7 +6909,7 @@
           <a:bodyPr wrap="square" rtlCol="0" anchor="ctr"/>
           <a:lstStyle/>
           <a:p>
-            <a:pPr indent="0" marL="0">
+            <a:pPr marL="0" indent="0">
               <a:buNone/>
             </a:pPr>
             <a:r>
@@ -7257,11 +6971,11 @@
           <a:bodyPr wrap="square" rtlCol="0" anchor="ctr"/>
           <a:lstStyle/>
           <a:p>
-            <a:pPr indent="0" marL="0">
-              <a:buNone/>
-            </a:pPr>
-            <a:r>
-              <a:rPr lang="en-US" sz="1200" b="1" spc="500" kern="0" dirty="0">
+            <a:pPr marL="0" indent="0">
+              <a:buNone/>
+            </a:pPr>
+            <a:r>
+              <a:rPr lang="en-US" sz="1200" b="1" kern="0" spc="500" dirty="0">
                 <a:solidFill>
                   <a:srgbClr val="7A7A7A"/>
                 </a:solidFill>
@@ -7296,7 +7010,7 @@
           <a:bodyPr wrap="square" rtlCol="0" anchor="ctr"/>
           <a:lstStyle/>
           <a:p>
-            <a:pPr indent="0" marL="0">
+            <a:pPr marL="0" indent="0">
               <a:buNone/>
             </a:pPr>
             <a:r>
@@ -7335,7 +7049,7 @@
           <a:bodyPr wrap="square" rtlCol="0" anchor="ctr"/>
           <a:lstStyle/>
           <a:p>
-            <a:pPr indent="0" marL="0">
+            <a:pPr marL="0" indent="0">
               <a:buNone/>
             </a:pPr>
             <a:r>
@@ -7347,9 +7061,118 @@
                 <a:ea typeface="Calibri" pitchFamily="34" charset="-122"/>
                 <a:cs typeface="Calibri" pitchFamily="34" charset="-120"/>
               </a:rPr>
-              <a:t>[ your-app-url ]    ·    [ your-email@kairo.app ]</a:t>
+              <a:t>[ </a:t>
+            </a:r>
+            <a:r>
+              <a:rPr lang="en-US" sz="1200" i="1" dirty="0" err="1">
+                <a:solidFill>
+                  <a:srgbClr val="5A5A5A"/>
+                </a:solidFill>
+                <a:latin typeface="Calibri" pitchFamily="34" charset="0"/>
+                <a:ea typeface="Calibri" pitchFamily="34" charset="-122"/>
+                <a:cs typeface="Calibri" pitchFamily="34" charset="-120"/>
+              </a:rPr>
+              <a:t>Dynamox</a:t>
+            </a:r>
+            <a:r>
+              <a:rPr lang="en-US" sz="1200" i="1" dirty="0">
+                <a:solidFill>
+                  <a:srgbClr val="5A5A5A"/>
+                </a:solidFill>
+                <a:latin typeface="Calibri" pitchFamily="34" charset="0"/>
+                <a:ea typeface="Calibri" pitchFamily="34" charset="-122"/>
+                <a:cs typeface="Calibri" pitchFamily="34" charset="-120"/>
+              </a:rPr>
+              <a:t> ]    ·    [ </a:t>
+            </a:r>
+            <a:r>
+              <a:rPr lang="en-US" sz="1200" i="1" dirty="0" err="1">
+                <a:solidFill>
+                  <a:srgbClr val="5A5A5A"/>
+                </a:solidFill>
+                <a:latin typeface="Calibri" pitchFamily="34" charset="0"/>
+                <a:ea typeface="Calibri" pitchFamily="34" charset="-122"/>
+                <a:cs typeface="Calibri" pitchFamily="34" charset="-120"/>
+              </a:rPr>
+              <a:t>kairo</a:t>
+            </a:r>
+            <a:r>
+              <a:rPr lang="en-US" sz="1200" i="1" dirty="0">
+                <a:solidFill>
+                  <a:srgbClr val="5A5A5A"/>
+                </a:solidFill>
+                <a:latin typeface="Calibri" pitchFamily="34" charset="0"/>
+                <a:ea typeface="Calibri" pitchFamily="34" charset="-122"/>
+                <a:cs typeface="Calibri" pitchFamily="34" charset="-120"/>
+              </a:rPr>
+              <a:t>-daily-</a:t>
+            </a:r>
+            <a:r>
+              <a:rPr lang="en-US" sz="1200" i="1" dirty="0" err="1">
+                <a:solidFill>
+                  <a:srgbClr val="5A5A5A"/>
+                </a:solidFill>
+                <a:latin typeface="Calibri" pitchFamily="34" charset="0"/>
+                <a:ea typeface="Calibri" pitchFamily="34" charset="-122"/>
+                <a:cs typeface="Calibri" pitchFamily="34" charset="-120"/>
+              </a:rPr>
+              <a:t>edu.vercel.app</a:t>
+            </a:r>
+            <a:r>
+              <a:rPr lang="en-US" sz="1200" i="1" dirty="0">
+                <a:solidFill>
+                  <a:srgbClr val="5A5A5A"/>
+                </a:solidFill>
+                <a:latin typeface="Calibri" pitchFamily="34" charset="0"/>
+                <a:ea typeface="Calibri" pitchFamily="34" charset="-122"/>
+                <a:cs typeface="Calibri" pitchFamily="34" charset="-120"/>
+              </a:rPr>
+              <a:t> ]</a:t>
             </a:r>
             <a:endParaRPr lang="en-US" sz="1200" dirty="0"/>
+          </a:p>
+        </p:txBody>
+      </p:sp>
+      <p:sp>
+        <p:nvSpPr>
+          <p:cNvPr id="15" name="TextBox 14">
+            <a:extLst>
+              <a:ext uri="{FF2B5EF4-FFF2-40B4-BE49-F238E27FC236}">
+                <a16:creationId xmlns:a16="http://schemas.microsoft.com/office/drawing/2014/main" id="{FAC73599-34D3-CE1C-4A91-2203C20B8931}"/>
+              </a:ext>
+            </a:extLst>
+          </p:cNvPr>
+          <p:cNvSpPr txBox="1"/>
+          <p:nvPr/>
+        </p:nvSpPr>
+        <p:spPr>
+          <a:xfrm>
+            <a:off x="6893859" y="1599758"/>
+            <a:ext cx="7539317" cy="1015663"/>
+          </a:xfrm>
+          <a:prstGeom prst="rect">
+            <a:avLst/>
+          </a:prstGeom>
+          <a:noFill/>
+        </p:spPr>
+        <p:txBody>
+          <a:bodyPr wrap="square">
+            <a:spAutoFit/>
+          </a:bodyPr>
+          <a:lstStyle/>
+          <a:p>
+            <a:r>
+              <a:rPr lang="en-US" sz="6000" b="1" dirty="0">
+                <a:solidFill>
+                  <a:srgbClr val="FFFFFF"/>
+                </a:solidFill>
+                <a:latin typeface="Calibri" pitchFamily="34" charset="0"/>
+                <a:ea typeface="Calibri" pitchFamily="34" charset="-122"/>
+                <a:cs typeface="Calibri" pitchFamily="34" charset="-120"/>
+              </a:rPr>
+              <a:t>Thank you</a:t>
+            </a:r>
+            <a:endParaRPr lang="en-US" sz="6000" dirty="0"/>
           </a:p>
         </p:txBody>
       </p:sp>
@@ -7399,11 +7222,11 @@
           <a:bodyPr wrap="square" rtlCol="0" anchor="ctr"/>
           <a:lstStyle/>
           <a:p>
-            <a:pPr indent="0" marL="0">
-              <a:buNone/>
-            </a:pPr>
-            <a:r>
-              <a:rPr lang="en-US" sz="1000" b="1" spc="600" kern="0" dirty="0">
+            <a:pPr marL="0" indent="0">
+              <a:buNone/>
+            </a:pPr>
+            <a:r>
+              <a:rPr lang="en-US" sz="1000" b="1" kern="0" spc="600" dirty="0">
                 <a:solidFill>
                   <a:srgbClr val="7A7A7A"/>
                 </a:solidFill>
@@ -7438,7 +7261,7 @@
           <a:bodyPr wrap="square" rtlCol="0" anchor="t"/>
           <a:lstStyle/>
           <a:p>
-            <a:pPr indent="0" marL="0">
+            <a:pPr marL="0" indent="0">
               <a:buNone/>
             </a:pPr>
             <a:r>
@@ -7455,7 +7278,7 @@
             <a:endParaRPr lang="en-US" sz="4000" dirty="0"/>
           </a:p>
           <a:p>
-            <a:pPr indent="0" marL="0">
+            <a:pPr marL="0" indent="0">
               <a:buNone/>
             </a:pPr>
             <a:r>
@@ -7521,11 +7344,11 @@
           <a:bodyPr wrap="square" rtlCol="0" anchor="ctr"/>
           <a:lstStyle/>
           <a:p>
-            <a:pPr indent="0" marL="0">
-              <a:buNone/>
-            </a:pPr>
-            <a:r>
-              <a:rPr lang="en-US" sz="1100" b="1" spc="400" kern="0" dirty="0">
+            <a:pPr marL="0" indent="0">
+              <a:buNone/>
+            </a:pPr>
+            <a:r>
+              <a:rPr lang="en-US" sz="1100" b="1" kern="0" spc="400" dirty="0">
                 <a:solidFill>
                   <a:srgbClr val="7A7A7A"/>
                 </a:solidFill>
@@ -7560,7 +7383,7 @@
           <a:bodyPr wrap="square" rtlCol="0" anchor="ctr"/>
           <a:lstStyle/>
           <a:p>
-            <a:pPr indent="0" marL="0">
+            <a:pPr marL="0" indent="0">
               <a:buNone/>
             </a:pPr>
             <a:r>
@@ -7599,7 +7422,7 @@
           <a:bodyPr wrap="square" rtlCol="0" anchor="t"/>
           <a:lstStyle/>
           <a:p>
-            <a:pPr indent="0" marL="0">
+            <a:pPr marL="0" indent="0">
               <a:buNone/>
             </a:pPr>
             <a:r>
@@ -7665,11 +7488,11 @@
           <a:bodyPr wrap="square" rtlCol="0" anchor="ctr"/>
           <a:lstStyle/>
           <a:p>
-            <a:pPr indent="0" marL="0">
-              <a:buNone/>
-            </a:pPr>
-            <a:r>
-              <a:rPr lang="en-US" sz="1100" b="1" spc="400" kern="0" dirty="0">
+            <a:pPr marL="0" indent="0">
+              <a:buNone/>
+            </a:pPr>
+            <a:r>
+              <a:rPr lang="en-US" sz="1100" b="1" kern="0" spc="400" dirty="0">
                 <a:solidFill>
                   <a:srgbClr val="7A7A7A"/>
                 </a:solidFill>
@@ -7704,7 +7527,7 @@
           <a:bodyPr wrap="square" rtlCol="0" anchor="ctr"/>
           <a:lstStyle/>
           <a:p>
-            <a:pPr indent="0" marL="0">
+            <a:pPr marL="0" indent="0">
               <a:buNone/>
             </a:pPr>
             <a:r>
@@ -7743,7 +7566,7 @@
           <a:bodyPr wrap="square" rtlCol="0" anchor="t"/>
           <a:lstStyle/>
           <a:p>
-            <a:pPr indent="0" marL="0">
+            <a:pPr marL="0" indent="0">
               <a:buNone/>
             </a:pPr>
             <a:r>
@@ -7809,11 +7632,11 @@
           <a:bodyPr wrap="square" rtlCol="0" anchor="ctr"/>
           <a:lstStyle/>
           <a:p>
-            <a:pPr indent="0" marL="0">
-              <a:buNone/>
-            </a:pPr>
-            <a:r>
-              <a:rPr lang="en-US" sz="1100" b="1" spc="400" kern="0" dirty="0">
+            <a:pPr marL="0" indent="0">
+              <a:buNone/>
+            </a:pPr>
+            <a:r>
+              <a:rPr lang="en-US" sz="1100" b="1" kern="0" spc="400" dirty="0">
                 <a:solidFill>
                   <a:srgbClr val="7A7A7A"/>
                 </a:solidFill>
@@ -7848,7 +7671,7 @@
           <a:bodyPr wrap="square" rtlCol="0" anchor="ctr"/>
           <a:lstStyle/>
           <a:p>
-            <a:pPr indent="0" marL="0">
+            <a:pPr marL="0" indent="0">
               <a:buNone/>
             </a:pPr>
             <a:r>
@@ -7887,7 +7710,7 @@
           <a:bodyPr wrap="square" rtlCol="0" anchor="t"/>
           <a:lstStyle/>
           <a:p>
-            <a:pPr indent="0" marL="0">
+            <a:pPr marL="0" indent="0">
               <a:buNone/>
             </a:pPr>
             <a:r>
@@ -7951,11 +7774,11 @@
           <a:bodyPr wrap="square" rtlCol="0" anchor="ctr"/>
           <a:lstStyle/>
           <a:p>
-            <a:pPr indent="0" marL="0">
-              <a:buNone/>
-            </a:pPr>
-            <a:r>
-              <a:rPr lang="en-US" sz="1000" b="1" spc="600" kern="0" dirty="0">
+            <a:pPr marL="0" indent="0">
+              <a:buNone/>
+            </a:pPr>
+            <a:r>
+              <a:rPr lang="en-US" sz="1000" b="1" kern="0" spc="600" dirty="0">
                 <a:solidFill>
                   <a:srgbClr val="7A7A7A"/>
                 </a:solidFill>
@@ -7990,7 +7813,7 @@
           <a:bodyPr wrap="square" rtlCol="0" anchor="t"/>
           <a:lstStyle/>
           <a:p>
-            <a:pPr indent="0" marL="0">
+            <a:pPr marL="0" indent="0">
               <a:buNone/>
             </a:pPr>
             <a:r>
@@ -8007,7 +7830,7 @@
             <a:endParaRPr lang="en-US" sz="4000" dirty="0"/>
           </a:p>
           <a:p>
-            <a:pPr indent="0" marL="0">
+            <a:pPr marL="0" indent="0">
               <a:buNone/>
             </a:pPr>
             <a:r>
@@ -8069,7 +7892,7 @@
           <a:bodyPr wrap="square" rtlCol="0" anchor="ctr"/>
           <a:lstStyle/>
           <a:p>
-            <a:pPr indent="0" marL="0">
+            <a:pPr marL="0" indent="0">
               <a:buNone/>
             </a:pPr>
             <a:r>
@@ -8108,7 +7931,7 @@
           <a:bodyPr wrap="square" rtlCol="0" anchor="ctr"/>
           <a:lstStyle/>
           <a:p>
-            <a:pPr algn="r" indent="0" marL="0">
+            <a:pPr marL="0" indent="0" algn="r">
               <a:buNone/>
             </a:pPr>
             <a:r>
@@ -8170,7 +7993,7 @@
           <a:bodyPr wrap="square" rtlCol="0" anchor="ctr"/>
           <a:lstStyle/>
           <a:p>
-            <a:pPr indent="0" marL="0">
+            <a:pPr marL="0" indent="0">
               <a:buNone/>
             </a:pPr>
             <a:r>
@@ -8209,7 +8032,7 @@
           <a:bodyPr wrap="square" rtlCol="0" anchor="ctr"/>
           <a:lstStyle/>
           <a:p>
-            <a:pPr algn="r" indent="0" marL="0">
+            <a:pPr marL="0" indent="0" algn="r">
               <a:buNone/>
             </a:pPr>
             <a:r>
@@ -8271,7 +8094,7 @@
           <a:bodyPr wrap="square" rtlCol="0" anchor="ctr"/>
           <a:lstStyle/>
           <a:p>
-            <a:pPr indent="0" marL="0">
+            <a:pPr marL="0" indent="0">
               <a:buNone/>
             </a:pPr>
             <a:r>
@@ -8310,7 +8133,7 @@
           <a:bodyPr wrap="square" rtlCol="0" anchor="ctr"/>
           <a:lstStyle/>
           <a:p>
-            <a:pPr algn="r" indent="0" marL="0">
+            <a:pPr marL="0" indent="0" algn="r">
               <a:buNone/>
             </a:pPr>
             <a:r>
@@ -8372,7 +8195,7 @@
           <a:bodyPr wrap="square" rtlCol="0" anchor="ctr"/>
           <a:lstStyle/>
           <a:p>
-            <a:pPr indent="0" marL="0">
+            <a:pPr marL="0" indent="0">
               <a:buNone/>
             </a:pPr>
             <a:r>
@@ -8411,7 +8234,7 @@
           <a:bodyPr wrap="square" rtlCol="0" anchor="ctr"/>
           <a:lstStyle/>
           <a:p>
-            <a:pPr algn="r" indent="0" marL="0">
+            <a:pPr marL="0" indent="0" algn="r">
               <a:buNone/>
             </a:pPr>
             <a:r>
@@ -8473,7 +8296,7 @@
           <a:bodyPr wrap="square" rtlCol="0" anchor="ctr"/>
           <a:lstStyle/>
           <a:p>
-            <a:pPr indent="0" marL="0">
+            <a:pPr marL="0" indent="0">
               <a:buNone/>
             </a:pPr>
             <a:r>
@@ -8512,7 +8335,7 @@
           <a:bodyPr wrap="square" rtlCol="0" anchor="ctr"/>
           <a:lstStyle/>
           <a:p>
-            <a:pPr algn="r" indent="0" marL="0">
+            <a:pPr marL="0" indent="0" algn="r">
               <a:buNone/>
             </a:pPr>
             <a:r>
@@ -8574,7 +8397,7 @@
           <a:bodyPr wrap="square" rtlCol="0" anchor="ctr"/>
           <a:lstStyle/>
           <a:p>
-            <a:pPr indent="0" marL="0">
+            <a:pPr marL="0" indent="0">
               <a:buNone/>
             </a:pPr>
             <a:r>
@@ -8613,7 +8436,7 @@
           <a:bodyPr wrap="square" rtlCol="0" anchor="ctr"/>
           <a:lstStyle/>
           <a:p>
-            <a:pPr algn="r" indent="0" marL="0">
+            <a:pPr marL="0" indent="0" algn="r">
               <a:buNone/>
             </a:pPr>
             <a:r>
@@ -8675,7 +8498,7 @@
           <a:bodyPr wrap="square" rtlCol="0" anchor="ctr"/>
           <a:lstStyle/>
           <a:p>
-            <a:pPr indent="0" marL="0">
+            <a:pPr marL="0" indent="0">
               <a:buNone/>
             </a:pPr>
             <a:r>
@@ -8714,7 +8537,7 @@
           <a:bodyPr wrap="square" rtlCol="0" anchor="ctr"/>
           <a:lstStyle/>
           <a:p>
-            <a:pPr algn="r" indent="0" marL="0">
+            <a:pPr marL="0" indent="0" algn="r">
               <a:buNone/>
             </a:pPr>
             <a:r>
@@ -8776,7 +8599,7 @@
           <a:bodyPr wrap="square" rtlCol="0" anchor="ctr"/>
           <a:lstStyle/>
           <a:p>
-            <a:pPr indent="0" marL="0">
+            <a:pPr marL="0" indent="0">
               <a:buNone/>
             </a:pPr>
             <a:r>
@@ -8815,7 +8638,7 @@
           <a:bodyPr wrap="square" rtlCol="0" anchor="ctr"/>
           <a:lstStyle/>
           <a:p>
-            <a:pPr algn="r" indent="0" marL="0">
+            <a:pPr marL="0" indent="0" algn="r">
               <a:buNone/>
             </a:pPr>
             <a:r>
@@ -8877,7 +8700,7 @@
           <a:bodyPr wrap="square" rtlCol="0" anchor="ctr"/>
           <a:lstStyle/>
           <a:p>
-            <a:pPr indent="0" marL="0">
+            <a:pPr marL="0" indent="0">
               <a:buNone/>
             </a:pPr>
             <a:r>
@@ -8916,7 +8739,7 @@
           <a:bodyPr wrap="square" rtlCol="0" anchor="ctr"/>
           <a:lstStyle/>
           <a:p>
-            <a:pPr algn="r" indent="0" marL="0">
+            <a:pPr marL="0" indent="0" algn="r">
               <a:buNone/>
             </a:pPr>
             <a:r>
@@ -8978,7 +8801,7 @@
           <a:bodyPr wrap="square" rtlCol="0" anchor="ctr"/>
           <a:lstStyle/>
           <a:p>
-            <a:pPr indent="0" marL="0">
+            <a:pPr marL="0" indent="0">
               <a:buNone/>
             </a:pPr>
             <a:r>
@@ -9017,7 +8840,7 @@
           <a:bodyPr wrap="square" rtlCol="0" anchor="ctr"/>
           <a:lstStyle/>
           <a:p>
-            <a:pPr algn="r" indent="0" marL="0">
+            <a:pPr marL="0" indent="0" algn="r">
               <a:buNone/>
             </a:pPr>
             <a:r>
@@ -9081,11 +8904,11 @@
           <a:bodyPr wrap="square" rtlCol="0" anchor="ctr"/>
           <a:lstStyle/>
           <a:p>
-            <a:pPr indent="0" marL="0">
-              <a:buNone/>
-            </a:pPr>
-            <a:r>
-              <a:rPr lang="en-US" sz="1000" b="1" spc="600" kern="0" dirty="0">
+            <a:pPr marL="0" indent="0">
+              <a:buNone/>
+            </a:pPr>
+            <a:r>
+              <a:rPr lang="en-US" sz="1000" b="1" kern="0" spc="600" dirty="0">
                 <a:solidFill>
                   <a:srgbClr val="7A7A7A"/>
                 </a:solidFill>
@@ -9120,7 +8943,7 @@
           <a:bodyPr wrap="square" rtlCol="0" anchor="t"/>
           <a:lstStyle/>
           <a:p>
-            <a:pPr indent="0" marL="0">
+            <a:pPr marL="0" indent="0">
               <a:buNone/>
             </a:pPr>
             <a:r>
@@ -9159,7 +8982,7 @@
           <a:bodyPr wrap="square" rtlCol="0" anchor="t"/>
           <a:lstStyle/>
           <a:p>
-            <a:pPr indent="0" marL="0">
+            <a:pPr marL="0" indent="0">
               <a:buNone/>
             </a:pPr>
             <a:r>
@@ -9225,7 +9048,7 @@
           <a:bodyPr wrap="square" rtlCol="0" anchor="ctr"/>
           <a:lstStyle/>
           <a:p>
-            <a:pPr indent="0" marL="0">
+            <a:pPr marL="0" indent="0">
               <a:buNone/>
             </a:pPr>
             <a:r>
@@ -9264,11 +9087,11 @@
           <a:bodyPr wrap="square" rtlCol="0" anchor="ctr"/>
           <a:lstStyle/>
           <a:p>
-            <a:pPr indent="0" marL="0">
-              <a:buNone/>
-            </a:pPr>
-            <a:r>
-              <a:rPr lang="en-US" sz="1100" b="1" spc="400" kern="0" dirty="0">
+            <a:pPr marL="0" indent="0">
+              <a:buNone/>
+            </a:pPr>
+            <a:r>
+              <a:rPr lang="en-US" sz="1100" b="1" kern="0" spc="400" dirty="0">
                 <a:solidFill>
                   <a:srgbClr val="7A7A7A"/>
                 </a:solidFill>
@@ -9303,7 +9126,7 @@
           <a:bodyPr wrap="square" rtlCol="0" anchor="ctr"/>
           <a:lstStyle/>
           <a:p>
-            <a:pPr indent="0" marL="0">
+            <a:pPr marL="0" indent="0">
               <a:buNone/>
             </a:pPr>
             <a:r>
@@ -9369,7 +9192,7 @@
           <a:bodyPr wrap="square" rtlCol="0" anchor="ctr"/>
           <a:lstStyle/>
           <a:p>
-            <a:pPr indent="0" marL="0">
+            <a:pPr marL="0" indent="0">
               <a:buNone/>
             </a:pPr>
             <a:r>
@@ -9408,11 +9231,11 @@
           <a:bodyPr wrap="square" rtlCol="0" anchor="ctr"/>
           <a:lstStyle/>
           <a:p>
-            <a:pPr indent="0" marL="0">
-              <a:buNone/>
-            </a:pPr>
-            <a:r>
-              <a:rPr lang="en-US" sz="1100" b="1" spc="400" kern="0" dirty="0">
+            <a:pPr marL="0" indent="0">
+              <a:buNone/>
+            </a:pPr>
+            <a:r>
+              <a:rPr lang="en-US" sz="1100" b="1" kern="0" spc="400" dirty="0">
                 <a:solidFill>
                   <a:srgbClr val="7A7A7A"/>
                 </a:solidFill>
@@ -9447,7 +9270,7 @@
           <a:bodyPr wrap="square" rtlCol="0" anchor="ctr"/>
           <a:lstStyle/>
           <a:p>
-            <a:pPr indent="0" marL="0">
+            <a:pPr marL="0" indent="0">
               <a:buNone/>
             </a:pPr>
             <a:r>
@@ -9513,7 +9336,7 @@
           <a:bodyPr wrap="square" rtlCol="0" anchor="ctr"/>
           <a:lstStyle/>
           <a:p>
-            <a:pPr indent="0" marL="0">
+            <a:pPr marL="0" indent="0">
               <a:buNone/>
             </a:pPr>
             <a:r>
@@ -9552,11 +9375,11 @@
           <a:bodyPr wrap="square" rtlCol="0" anchor="ctr"/>
           <a:lstStyle/>
           <a:p>
-            <a:pPr indent="0" marL="0">
-              <a:buNone/>
-            </a:pPr>
-            <a:r>
-              <a:rPr lang="en-US" sz="1100" b="1" spc="400" kern="0" dirty="0">
+            <a:pPr marL="0" indent="0">
+              <a:buNone/>
+            </a:pPr>
+            <a:r>
+              <a:rPr lang="en-US" sz="1100" b="1" kern="0" spc="400" dirty="0">
                 <a:solidFill>
                   <a:srgbClr val="7A7A7A"/>
                 </a:solidFill>
@@ -9591,7 +9414,7 @@
           <a:bodyPr wrap="square" rtlCol="0" anchor="ctr"/>
           <a:lstStyle/>
           <a:p>
-            <a:pPr indent="0" marL="0">
+            <a:pPr marL="0" indent="0">
               <a:buNone/>
             </a:pPr>
             <a:r>
@@ -9657,7 +9480,7 @@
           <a:bodyPr wrap="square" rtlCol="0" anchor="ctr"/>
           <a:lstStyle/>
           <a:p>
-            <a:pPr indent="0" marL="0">
+            <a:pPr marL="0" indent="0">
               <a:buNone/>
             </a:pPr>
             <a:r>
@@ -9696,11 +9519,11 @@
           <a:bodyPr wrap="square" rtlCol="0" anchor="ctr"/>
           <a:lstStyle/>
           <a:p>
-            <a:pPr indent="0" marL="0">
-              <a:buNone/>
-            </a:pPr>
-            <a:r>
-              <a:rPr lang="en-US" sz="1100" b="1" spc="400" kern="0" dirty="0">
+            <a:pPr marL="0" indent="0">
+              <a:buNone/>
+            </a:pPr>
+            <a:r>
+              <a:rPr lang="en-US" sz="1100" b="1" kern="0" spc="400" dirty="0">
                 <a:solidFill>
                   <a:srgbClr val="7A7A7A"/>
                 </a:solidFill>
@@ -9735,7 +9558,7 @@
           <a:bodyPr wrap="square" rtlCol="0" anchor="ctr"/>
           <a:lstStyle/>
           <a:p>
-            <a:pPr indent="0" marL="0">
+            <a:pPr marL="0" indent="0">
               <a:buNone/>
             </a:pPr>
             <a:r>
@@ -9774,7 +9597,7 @@
           <a:bodyPr wrap="square" rtlCol="0" anchor="ctr"/>
           <a:lstStyle/>
           <a:p>
-            <a:pPr indent="0" marL="0">
+            <a:pPr marL="0" indent="0">
               <a:buNone/>
             </a:pPr>
             <a:r>
@@ -9838,11 +9661,11 @@
           <a:bodyPr wrap="square" rtlCol="0" anchor="ctr"/>
           <a:lstStyle/>
           <a:p>
-            <a:pPr indent="0" marL="0">
-              <a:buNone/>
-            </a:pPr>
-            <a:r>
-              <a:rPr lang="en-US" sz="1000" b="1" spc="600" kern="0" dirty="0">
+            <a:pPr marL="0" indent="0">
+              <a:buNone/>
+            </a:pPr>
+            <a:r>
+              <a:rPr lang="en-US" sz="1000" b="1" kern="0" spc="600" dirty="0">
                 <a:solidFill>
                   <a:srgbClr val="7A7A7A"/>
                 </a:solidFill>
@@ -9877,7 +9700,7 @@
           <a:bodyPr wrap="square" rtlCol="0" anchor="t"/>
           <a:lstStyle/>
           <a:p>
-            <a:pPr indent="0" marL="0">
+            <a:pPr marL="0" indent="0">
               <a:buNone/>
             </a:pPr>
             <a:r>
@@ -9894,7 +9717,7 @@
             <a:endParaRPr lang="en-US" sz="4000" dirty="0"/>
           </a:p>
           <a:p>
-            <a:pPr indent="0" marL="0">
+            <a:pPr marL="0" indent="0">
               <a:buNone/>
             </a:pPr>
             <a:r>
@@ -9960,11 +9783,11 @@
           <a:bodyPr wrap="square" rtlCol="0" anchor="ctr"/>
           <a:lstStyle/>
           <a:p>
-            <a:pPr indent="0" marL="0">
-              <a:buNone/>
-            </a:pPr>
-            <a:r>
-              <a:rPr lang="en-US" sz="1000" b="1" spc="500" kern="0" dirty="0">
+            <a:pPr marL="0" indent="0">
+              <a:buNone/>
+            </a:pPr>
+            <a:r>
+              <a:rPr lang="en-US" sz="1000" b="1" kern="0" spc="500" dirty="0">
                 <a:solidFill>
                   <a:srgbClr val="7A7A7A"/>
                 </a:solidFill>
@@ -10153,11 +9976,11 @@
           <a:bodyPr wrap="square" rtlCol="0" anchor="ctr"/>
           <a:lstStyle/>
           <a:p>
-            <a:pPr indent="0" marL="0">
-              <a:buNone/>
-            </a:pPr>
-            <a:r>
-              <a:rPr lang="en-US" sz="1000" b="1" spc="500" kern="0" dirty="0">
+            <a:pPr marL="0" indent="0">
+              <a:buNone/>
+            </a:pPr>
+            <a:r>
+              <a:rPr lang="en-US" sz="1000" b="1" kern="0" spc="500" dirty="0">
                 <a:solidFill>
                   <a:srgbClr val="999999"/>
                 </a:solidFill>
@@ -10319,7 +10142,7 @@
           <a:bodyPr wrap="square" rtlCol="0" anchor="ctr"/>
           <a:lstStyle/>
           <a:p>
-            <a:pPr algn="ctr" indent="0" marL="0">
+            <a:pPr marL="0" indent="0" algn="ctr">
               <a:buNone/>
             </a:pPr>
             <a:r>
@@ -10383,11 +10206,11 @@
           <a:bodyPr wrap="square" rtlCol="0" anchor="ctr"/>
           <a:lstStyle/>
           <a:p>
-            <a:pPr indent="0" marL="0">
-              <a:buNone/>
-            </a:pPr>
-            <a:r>
-              <a:rPr lang="en-US" sz="1000" b="1" spc="600" kern="0" dirty="0">
+            <a:pPr marL="0" indent="0">
+              <a:buNone/>
+            </a:pPr>
+            <a:r>
+              <a:rPr lang="en-US" sz="1000" b="1" kern="0" spc="600" dirty="0">
                 <a:solidFill>
                   <a:srgbClr val="7A7A7A"/>
                 </a:solidFill>
@@ -10422,7 +10245,7 @@
           <a:bodyPr wrap="square" rtlCol="0" anchor="t"/>
           <a:lstStyle/>
           <a:p>
-            <a:pPr indent="0" marL="0">
+            <a:pPr marL="0" indent="0">
               <a:buNone/>
             </a:pPr>
             <a:r>
@@ -10439,7 +10262,7 @@
             <a:endParaRPr lang="en-US" sz="4000" dirty="0"/>
           </a:p>
           <a:p>
-            <a:pPr indent="0" marL="0">
+            <a:pPr marL="0" indent="0">
               <a:buNone/>
             </a:pPr>
             <a:r>
@@ -10465,7 +10288,7 @@
         </p:nvSpPr>
         <p:spPr>
           <a:xfrm>
-            <a:off x="548640" y="1920240"/>
+            <a:off x="548640" y="2331720"/>
             <a:ext cx="10515600" cy="548640"/>
           </a:xfrm>
           <a:prstGeom prst="rect">
@@ -10478,7 +10301,7 @@
           <a:bodyPr wrap="square" rtlCol="0" anchor="t"/>
           <a:lstStyle/>
           <a:p>
-            <a:pPr indent="0" marL="0">
+            <a:pPr marL="0" indent="0">
               <a:buNone/>
             </a:pPr>
             <a:r>
@@ -10544,11 +10367,11 @@
           <a:bodyPr wrap="square" rtlCol="0" anchor="ctr"/>
           <a:lstStyle/>
           <a:p>
-            <a:pPr indent="0" marL="0">
-              <a:buNone/>
-            </a:pPr>
-            <a:r>
-              <a:rPr lang="en-US" sz="1000" b="1" spc="500" kern="0" dirty="0">
+            <a:pPr marL="0" indent="0">
+              <a:buNone/>
+            </a:pPr>
+            <a:r>
+              <a:rPr lang="en-US" sz="1000" b="1" kern="0" spc="500" dirty="0">
                 <a:solidFill>
                   <a:srgbClr val="7A7A7A"/>
                 </a:solidFill>
@@ -10716,11 +10539,11 @@
           <a:bodyPr wrap="square" rtlCol="0" anchor="ctr"/>
           <a:lstStyle/>
           <a:p>
-            <a:pPr indent="0" marL="0">
-              <a:buNone/>
-            </a:pPr>
-            <a:r>
-              <a:rPr lang="en-US" sz="1000" b="1" spc="500" kern="0" dirty="0">
+            <a:pPr marL="0" indent="0">
+              <a:buNone/>
+            </a:pPr>
+            <a:r>
+              <a:rPr lang="en-US" sz="1000" b="1" kern="0" spc="500" dirty="0">
                 <a:solidFill>
                   <a:srgbClr val="FFFFFF"/>
                 </a:solidFill>
@@ -10861,7 +10684,7 @@
           <a:bodyPr wrap="square" rtlCol="0" anchor="ctr"/>
           <a:lstStyle/>
           <a:p>
-            <a:pPr indent="0" marL="0">
+            <a:pPr marL="0" indent="0">
               <a:buNone/>
             </a:pPr>
             <a:r>
@@ -10925,11 +10748,11 @@
           <a:bodyPr wrap="square" rtlCol="0" anchor="ctr"/>
           <a:lstStyle/>
           <a:p>
-            <a:pPr indent="0" marL="0">
-              <a:buNone/>
-            </a:pPr>
-            <a:r>
-              <a:rPr lang="en-US" sz="1000" b="1" spc="600" kern="0" dirty="0">
+            <a:pPr marL="0" indent="0">
+              <a:buNone/>
+            </a:pPr>
+            <a:r>
+              <a:rPr lang="en-US" sz="1000" b="1" kern="0" spc="600" dirty="0">
                 <a:solidFill>
                   <a:srgbClr val="7A7A7A"/>
                 </a:solidFill>
@@ -10964,7 +10787,7 @@
           <a:bodyPr wrap="square" rtlCol="0" anchor="t"/>
           <a:lstStyle/>
           <a:p>
-            <a:pPr indent="0" marL="0">
+            <a:pPr marL="0" indent="0">
               <a:buNone/>
             </a:pPr>
             <a:r>
@@ -10981,7 +10804,7 @@
             <a:endParaRPr lang="en-US" sz="4000" dirty="0"/>
           </a:p>
           <a:p>
-            <a:pPr indent="0" marL="0">
+            <a:pPr marL="0" indent="0">
               <a:buNone/>
             </a:pPr>
             <a:r>
@@ -11043,11 +10866,11 @@
           <a:bodyPr wrap="square" rtlCol="0" anchor="ctr"/>
           <a:lstStyle/>
           <a:p>
-            <a:pPr indent="0" marL="0">
-              <a:buNone/>
-            </a:pPr>
-            <a:r>
-              <a:rPr lang="en-US" sz="1200" b="1" spc="500" kern="0" dirty="0">
+            <a:pPr marL="0" indent="0">
+              <a:buNone/>
+            </a:pPr>
+            <a:r>
+              <a:rPr lang="en-US" sz="1200" b="1" kern="0" spc="500" dirty="0">
                 <a:solidFill>
                   <a:srgbClr val="7A7A7A"/>
                 </a:solidFill>
@@ -11082,7 +10905,7 @@
           <a:bodyPr wrap="square" rtlCol="0" anchor="ctr"/>
           <a:lstStyle/>
           <a:p>
-            <a:pPr indent="0" marL="0">
+            <a:pPr marL="0" indent="0">
               <a:buNone/>
             </a:pPr>
             <a:r>
@@ -11144,11 +10967,11 @@
           <a:bodyPr wrap="square" rtlCol="0" anchor="ctr"/>
           <a:lstStyle/>
           <a:p>
-            <a:pPr indent="0" marL="0">
-              <a:buNone/>
-            </a:pPr>
-            <a:r>
-              <a:rPr lang="en-US" sz="1200" b="1" spc="500" kern="0" dirty="0">
+            <a:pPr marL="0" indent="0">
+              <a:buNone/>
+            </a:pPr>
+            <a:r>
+              <a:rPr lang="en-US" sz="1200" b="1" kern="0" spc="500" dirty="0">
                 <a:solidFill>
                   <a:srgbClr val="7A7A7A"/>
                 </a:solidFill>
@@ -11183,7 +11006,7 @@
           <a:bodyPr wrap="square" rtlCol="0" anchor="ctr"/>
           <a:lstStyle/>
           <a:p>
-            <a:pPr indent="0" marL="0">
+            <a:pPr marL="0" indent="0">
               <a:buNone/>
             </a:pPr>
             <a:r>
@@ -11245,11 +11068,11 @@
           <a:bodyPr wrap="square" rtlCol="0" anchor="ctr"/>
           <a:lstStyle/>
           <a:p>
-            <a:pPr indent="0" marL="0">
-              <a:buNone/>
-            </a:pPr>
-            <a:r>
-              <a:rPr lang="en-US" sz="1200" b="1" spc="500" kern="0" dirty="0">
+            <a:pPr marL="0" indent="0">
+              <a:buNone/>
+            </a:pPr>
+            <a:r>
+              <a:rPr lang="en-US" sz="1200" b="1" kern="0" spc="500" dirty="0">
                 <a:solidFill>
                   <a:srgbClr val="7A7A7A"/>
                 </a:solidFill>
@@ -11284,7 +11107,7 @@
           <a:bodyPr wrap="square" rtlCol="0" anchor="ctr"/>
           <a:lstStyle/>
           <a:p>
-            <a:pPr indent="0" marL="0">
+            <a:pPr marL="0" indent="0">
               <a:buNone/>
             </a:pPr>
             <a:r>
@@ -11346,11 +11169,11 @@
           <a:bodyPr wrap="square" rtlCol="0" anchor="ctr"/>
           <a:lstStyle/>
           <a:p>
-            <a:pPr indent="0" marL="0">
-              <a:buNone/>
-            </a:pPr>
-            <a:r>
-              <a:rPr lang="en-US" sz="1200" b="1" spc="500" kern="0" dirty="0">
+            <a:pPr marL="0" indent="0">
+              <a:buNone/>
+            </a:pPr>
+            <a:r>
+              <a:rPr lang="en-US" sz="1200" b="1" kern="0" spc="500" dirty="0">
                 <a:solidFill>
                   <a:srgbClr val="7A7A7A"/>
                 </a:solidFill>
@@ -11385,7 +11208,7 @@
           <a:bodyPr wrap="square" rtlCol="0" anchor="ctr"/>
           <a:lstStyle/>
           <a:p>
-            <a:pPr indent="0" marL="0">
+            <a:pPr marL="0" indent="0">
               <a:buNone/>
             </a:pPr>
             <a:r>
@@ -11447,11 +11270,11 @@
           <a:bodyPr wrap="square" rtlCol="0" anchor="ctr"/>
           <a:lstStyle/>
           <a:p>
-            <a:pPr indent="0" marL="0">
-              <a:buNone/>
-            </a:pPr>
-            <a:r>
-              <a:rPr lang="en-US" sz="1200" b="1" spc="500" kern="0" dirty="0">
+            <a:pPr marL="0" indent="0">
+              <a:buNone/>
+            </a:pPr>
+            <a:r>
+              <a:rPr lang="en-US" sz="1200" b="1" kern="0" spc="500" dirty="0">
                 <a:solidFill>
                   <a:srgbClr val="7A7A7A"/>
                 </a:solidFill>
@@ -11486,7 +11309,7 @@
           <a:bodyPr wrap="square" rtlCol="0" anchor="ctr"/>
           <a:lstStyle/>
           <a:p>
-            <a:pPr indent="0" marL="0">
+            <a:pPr marL="0" indent="0">
               <a:buNone/>
             </a:pPr>
             <a:r>
@@ -11525,7 +11348,7 @@
           <a:bodyPr wrap="square" rtlCol="0" anchor="ctr"/>
           <a:lstStyle/>
           <a:p>
-            <a:pPr indent="0" marL="0">
+            <a:pPr marL="0" indent="0">
               <a:buNone/>
             </a:pPr>
             <a:r>
@@ -11589,11 +11412,11 @@
           <a:bodyPr wrap="square" rtlCol="0" anchor="ctr"/>
           <a:lstStyle/>
           <a:p>
-            <a:pPr indent="0" marL="0">
-              <a:buNone/>
-            </a:pPr>
-            <a:r>
-              <a:rPr lang="en-US" sz="1000" b="1" spc="600" kern="0" dirty="0">
+            <a:pPr marL="0" indent="0">
+              <a:buNone/>
+            </a:pPr>
+            <a:r>
+              <a:rPr lang="en-US" sz="1000" b="1" kern="0" spc="600" dirty="0">
                 <a:solidFill>
                   <a:srgbClr val="7A7A7A"/>
                 </a:solidFill>
@@ -11628,7 +11451,7 @@
           <a:bodyPr wrap="square" rtlCol="0" anchor="t"/>
           <a:lstStyle/>
           <a:p>
-            <a:pPr indent="0" marL="0">
+            <a:pPr marL="0" indent="0">
               <a:buNone/>
             </a:pPr>
             <a:r>
@@ -11645,7 +11468,7 @@
             <a:endParaRPr lang="en-US" sz="4000" dirty="0"/>
           </a:p>
           <a:p>
-            <a:pPr indent="0" marL="0">
+            <a:pPr marL="0" indent="0">
               <a:buNone/>
             </a:pPr>
             <a:r>
@@ -11662,7 +11485,7 @@
             <a:endParaRPr lang="en-US" sz="4000" dirty="0"/>
           </a:p>
           <a:p>
-            <a:pPr indent="0" marL="0">
+            <a:pPr marL="0" indent="0">
               <a:buNone/>
             </a:pPr>
             <a:r>
@@ -11728,11 +11551,11 @@
           <a:bodyPr wrap="square" rtlCol="0" anchor="ctr"/>
           <a:lstStyle/>
           <a:p>
-            <a:pPr indent="0" marL="0">
-              <a:buNone/>
-            </a:pPr>
-            <a:r>
-              <a:rPr lang="en-US" sz="1100" b="1" spc="500" kern="0" dirty="0">
+            <a:pPr marL="0" indent="0">
+              <a:buNone/>
+            </a:pPr>
+            <a:r>
+              <a:rPr lang="en-US" sz="1100" b="1" kern="0" spc="500" dirty="0">
                 <a:solidFill>
                   <a:srgbClr val="7A7A7A"/>
                 </a:solidFill>
@@ -11767,7 +11590,7 @@
           <a:bodyPr wrap="square" rtlCol="0" anchor="ctr"/>
           <a:lstStyle/>
           <a:p>
-            <a:pPr indent="0" marL="0">
+            <a:pPr marL="0" indent="0">
               <a:buNone/>
             </a:pPr>
             <a:r>
@@ -11833,11 +11656,11 @@
           <a:bodyPr wrap="square" rtlCol="0" anchor="ctr"/>
           <a:lstStyle/>
           <a:p>
-            <a:pPr indent="0" marL="0">
-              <a:buNone/>
-            </a:pPr>
-            <a:r>
-              <a:rPr lang="en-US" sz="1100" b="1" spc="500" kern="0" dirty="0">
+            <a:pPr marL="0" indent="0">
+              <a:buNone/>
+            </a:pPr>
+            <a:r>
+              <a:rPr lang="en-US" sz="1100" b="1" kern="0" spc="500" dirty="0">
                 <a:solidFill>
                   <a:srgbClr val="7A7A7A"/>
                 </a:solidFill>
@@ -11872,7 +11695,7 @@
           <a:bodyPr wrap="square" rtlCol="0" anchor="ctr"/>
           <a:lstStyle/>
           <a:p>
-            <a:pPr indent="0" marL="0">
+            <a:pPr marL="0" indent="0">
               <a:buNone/>
             </a:pPr>
             <a:r>
@@ -11938,11 +11761,11 @@
           <a:bodyPr wrap="square" rtlCol="0" anchor="ctr"/>
           <a:lstStyle/>
           <a:p>
-            <a:pPr indent="0" marL="0">
-              <a:buNone/>
-            </a:pPr>
-            <a:r>
-              <a:rPr lang="en-US" sz="1100" b="1" spc="500" kern="0" dirty="0">
+            <a:pPr marL="0" indent="0">
+              <a:buNone/>
+            </a:pPr>
+            <a:r>
+              <a:rPr lang="en-US" sz="1100" b="1" kern="0" spc="500" dirty="0">
                 <a:solidFill>
                   <a:srgbClr val="7A7A7A"/>
                 </a:solidFill>
@@ -11977,7 +11800,7 @@
           <a:bodyPr wrap="square" rtlCol="0" anchor="ctr"/>
           <a:lstStyle/>
           <a:p>
-            <a:pPr indent="0" marL="0">
+            <a:pPr marL="0" indent="0">
               <a:buNone/>
             </a:pPr>
             <a:r>
@@ -12043,11 +11866,11 @@
           <a:bodyPr wrap="square" rtlCol="0" anchor="ctr"/>
           <a:lstStyle/>
           <a:p>
-            <a:pPr indent="0" marL="0">
-              <a:buNone/>
-            </a:pPr>
-            <a:r>
-              <a:rPr lang="en-US" sz="1100" b="1" spc="500" kern="0" dirty="0">
+            <a:pPr marL="0" indent="0">
+              <a:buNone/>
+            </a:pPr>
+            <a:r>
+              <a:rPr lang="en-US" sz="1100" b="1" kern="0" spc="500" dirty="0">
                 <a:solidFill>
                   <a:srgbClr val="7A7A7A"/>
                 </a:solidFill>
@@ -12082,7 +11905,7 @@
           <a:bodyPr wrap="square" rtlCol="0" anchor="ctr"/>
           <a:lstStyle/>
           <a:p>
-            <a:pPr indent="0" marL="0">
+            <a:pPr marL="0" indent="0">
               <a:buNone/>
             </a:pPr>
             <a:r>
@@ -12146,11 +11969,11 @@
           <a:bodyPr wrap="square" rtlCol="0" anchor="ctr"/>
           <a:lstStyle/>
           <a:p>
-            <a:pPr indent="0" marL="0">
-              <a:buNone/>
-            </a:pPr>
-            <a:r>
-              <a:rPr lang="en-US" sz="1000" b="1" spc="600" kern="0" dirty="0">
+            <a:pPr marL="0" indent="0">
+              <a:buNone/>
+            </a:pPr>
+            <a:r>
+              <a:rPr lang="en-US" sz="1000" b="1" kern="0" spc="600" dirty="0">
                 <a:solidFill>
                   <a:srgbClr val="7A7A7A"/>
                 </a:solidFill>
@@ -12185,7 +12008,7 @@
           <a:bodyPr wrap="square" rtlCol="0" anchor="t"/>
           <a:lstStyle/>
           <a:p>
-            <a:pPr indent="0" marL="0">
+            <a:pPr marL="0" indent="0">
               <a:buNone/>
             </a:pPr>
             <a:r>
@@ -12202,7 +12025,7 @@
             <a:endParaRPr lang="en-US" sz="4000" dirty="0"/>
           </a:p>
           <a:p>
-            <a:pPr indent="0" marL="0">
+            <a:pPr marL="0" indent="0">
               <a:buNone/>
             </a:pPr>
             <a:r>
@@ -12264,7 +12087,7 @@
           <a:bodyPr wrap="square" rtlCol="0" anchor="ctr"/>
           <a:lstStyle/>
           <a:p>
-            <a:pPr indent="0" marL="0">
+            <a:pPr marL="0" indent="0">
               <a:buNone/>
             </a:pPr>
             <a:r>
@@ -12326,7 +12149,7 @@
           <a:bodyPr wrap="square" rtlCol="0" anchor="ctr"/>
           <a:lstStyle/>
           <a:p>
-            <a:pPr indent="0" marL="0">
+            <a:pPr marL="0" indent="0">
               <a:buNone/>
             </a:pPr>
             <a:r>
@@ -12388,7 +12211,7 @@
           <a:bodyPr wrap="square" rtlCol="0" anchor="ctr"/>
           <a:lstStyle/>
           <a:p>
-            <a:pPr indent="0" marL="0">
+            <a:pPr marL="0" indent="0">
               <a:buNone/>
             </a:pPr>
             <a:r>
@@ -12450,7 +12273,7 @@
           <a:bodyPr wrap="square" rtlCol="0" anchor="ctr"/>
           <a:lstStyle/>
           <a:p>
-            <a:pPr indent="0" marL="0">
+            <a:pPr marL="0" indent="0">
               <a:buNone/>
             </a:pPr>
             <a:r>
@@ -12512,7 +12335,7 @@
           <a:bodyPr wrap="square" rtlCol="0" anchor="ctr"/>
           <a:lstStyle/>
           <a:p>
-            <a:pPr indent="0" marL="0">
+            <a:pPr marL="0" indent="0">
               <a:buNone/>
             </a:pPr>
             <a:r>
@@ -12551,7 +12374,7 @@
           <a:bodyPr wrap="square" rtlCol="0" anchor="ctr"/>
           <a:lstStyle/>
           <a:p>
-            <a:pPr indent="0" marL="0">
+            <a:pPr marL="0" indent="0">
               <a:buNone/>
             </a:pPr>
             <a:r>
@@ -12870,4 +12693,299 @@
     </a:ext>
   </a:extLst>
 </a:theme>
+</file>
+
+<file path=ppt/theme/theme2.xml><?xml version="1.0" encoding="utf-8"?>
+<a:theme xmlns:a="http://schemas.openxmlformats.org/drawingml/2006/main" name="Office Theme">
+  <a:themeElements>
+    <a:clrScheme name="Office">
+      <a:dk1>
+        <a:sysClr val="windowText" lastClr="000000"/>
+      </a:dk1>
+      <a:lt1>
+        <a:sysClr val="window" lastClr="FFFFFF"/>
+      </a:lt1>
+      <a:dk2>
+        <a:srgbClr val="44546A"/>
+      </a:dk2>
+      <a:lt2>
+        <a:srgbClr val="E7E6E6"/>
+      </a:lt2>
+      <a:accent1>
+        <a:srgbClr val="4472C4"/>
+      </a:accent1>
+      <a:accent2>
+        <a:srgbClr val="ED7D31"/>
+      </a:accent2>
+      <a:accent3>
+        <a:srgbClr val="A5A5A5"/>
+      </a:accent3>
+      <a:accent4>
+        <a:srgbClr val="FFC000"/>
+      </a:accent4>
+      <a:accent5>
+        <a:srgbClr val="5B9BD5"/>
+      </a:accent5>
+      <a:accent6>
+        <a:srgbClr val="70AD47"/>
+      </a:accent6>
+      <a:hlink>
+        <a:srgbClr val="0563C1"/>
+      </a:hlink>
+      <a:folHlink>
+        <a:srgbClr val="954F72"/>
+      </a:folHlink>
+    </a:clrScheme>
+    <a:fontScheme name="Office">
+      <a:majorFont>
+        <a:latin typeface="Calibri Light" panose="020F0302020204030204"/>
+        <a:ea typeface=""/>
+        <a:cs typeface=""/>
+        <a:font script="Jpan" typeface="游ゴシック Light"/>
+        <a:font script="Hang" typeface="맑은 고딕"/>
+        <a:font script="Hans" typeface="等线 Light"/>
+        <a:font script="Hant" typeface="新細明體"/>
+        <a:font script="Arab" typeface="Times New Roman"/>
+        <a:font script="Hebr" typeface="Times New Roman"/>
+        <a:font script="Thai" typeface="Angsana New"/>
+        <a:font script="Ethi" typeface="Nyala"/>
+        <a:font script="Beng" typeface="Vrinda"/>
+        <a:font script="Gujr" typeface="Shruti"/>
+        <a:font script="Khmr" typeface="MoolBoran"/>
+        <a:font script="Knda" typeface="Tunga"/>
+        <a:font script="Guru" typeface="Raavi"/>
+        <a:font script="Cans" typeface="Euphemia"/>
+        <a:font script="Cher" typeface="Plantagenet Cherokee"/>
+        <a:font script="Yiii" typeface="Microsoft Yi Baiti"/>
+        <a:font script="Tibt" typeface="Microsoft Himalaya"/>
+        <a:font script="Thaa" typeface="MV Boli"/>
+        <a:font script="Deva" typeface="Mangal"/>
+        <a:font script="Telu" typeface="Gautami"/>
+        <a:font script="Taml" typeface="Latha"/>
+        <a:font script="Syrc" typeface="Estrangelo Edessa"/>
+        <a:font script="Orya" typeface="Kalinga"/>
+        <a:font script="Mlym" typeface="Kartika"/>
+        <a:font script="Laoo" typeface="DokChampa"/>
+        <a:font script="Sinh" typeface="Iskoola Pota"/>
+        <a:font script="Mong" typeface="Mongolian Baiti"/>
+        <a:font script="Viet" typeface="Times New Roman"/>
+        <a:font script="Uigh" typeface="Microsoft Uighur"/>
+        <a:font script="Geor" typeface="Sylfaen"/>
+        <a:font script="Armn" typeface="Arial"/>
+        <a:font script="Bugi" typeface="Leelawadee UI"/>
+        <a:font script="Bopo" typeface="Microsoft JhengHei"/>
+        <a:font script="Java" typeface="Javanese Text"/>
+        <a:font script="Lisu" typeface="Segoe UI"/>
+        <a:font script="Mymr" typeface="Myanmar Text"/>
+        <a:font script="Nkoo" typeface="Ebrima"/>
+        <a:font script="Olck" typeface="Nirmala UI"/>
+        <a:font script="Osma" typeface="Ebrima"/>
+        <a:font script="Phag" typeface="Phagspa"/>
+        <a:font script="Syrn" typeface="Estrangelo Edessa"/>
+        <a:font script="Syrj" typeface="Estrangelo Edessa"/>
+        <a:font script="Syre" typeface="Estrangelo Edessa"/>
+        <a:font script="Sora" typeface="Nirmala UI"/>
+        <a:font script="Tale" typeface="Microsoft Tai Le"/>
+        <a:font script="Talu" typeface="Microsoft New Tai Lue"/>
+        <a:font script="Tfng" typeface="Ebrima"/>
+      </a:majorFont>
+      <a:minorFont>
+        <a:latin typeface="Calibri" panose="020F0502020204030204"/>
+        <a:ea typeface=""/>
+        <a:cs typeface=""/>
+        <a:font script="Jpan" typeface="游ゴシック"/>
+        <a:font script="Hang" typeface="맑은 고딕"/>
+        <a:font script="Hans" typeface="等线"/>
+        <a:font script="Hant" typeface="新細明體"/>
+        <a:font script="Arab" typeface="Arial"/>
+        <a:font script="Hebr" typeface="Arial"/>
+        <a:font script="Thai" typeface="Cordia New"/>
+        <a:font script="Ethi" typeface="Nyala"/>
+        <a:font script="Beng" typeface="Vrinda"/>
+        <a:font script="Gujr" typeface="Shruti"/>
+        <a:font script="Khmr" typeface="DaunPenh"/>
+        <a:font script="Knda" typeface="Tunga"/>
+        <a:font script="Guru" typeface="Raavi"/>
+        <a:font script="Cans" typeface="Euphemia"/>
+        <a:font script="Cher" typeface="Plantagenet Cherokee"/>
+        <a:font script="Yiii" typeface="Microsoft Yi Baiti"/>
+        <a:font script="Tibt" typeface="Microsoft Himalaya"/>
+        <a:font script="Thaa" typeface="MV Boli"/>
+        <a:font script="Deva" typeface="Mangal"/>
+        <a:font script="Telu" typeface="Gautami"/>
+        <a:font script="Taml" typeface="Latha"/>
+        <a:font script="Syrc" typeface="Estrangelo Edessa"/>
+        <a:font script="Orya" typeface="Kalinga"/>
+        <a:font script="Mlym" typeface="Kartika"/>
+        <a:font script="Laoo" typeface="DokChampa"/>
+        <a:font script="Sinh" typeface="Iskoola Pota"/>
+        <a:font script="Mong" typeface="Mongolian Baiti"/>
+        <a:font script="Viet" typeface="Arial"/>
+        <a:font script="Uigh" typeface="Microsoft Uighur"/>
+        <a:font script="Geor" typeface="Sylfaen"/>
+        <a:font script="Armn" typeface="Arial"/>
+        <a:font script="Bugi" typeface="Leelawadee UI"/>
+        <a:font script="Bopo" typeface="Microsoft JhengHei"/>
+        <a:font script="Java" typeface="Javanese Text"/>
+        <a:font script="Lisu" typeface="Segoe UI"/>
+        <a:font script="Mymr" typeface="Myanmar Text"/>
+        <a:font script="Nkoo" typeface="Ebrima"/>
+        <a:font script="Olck" typeface="Nirmala UI"/>
+        <a:font script="Osma" typeface="Ebrima"/>
+        <a:font script="Phag" typeface="Phagspa"/>
+        <a:font script="Syrn" typeface="Estrangelo Edessa"/>
+        <a:font script="Syrj" typeface="Estrangelo Edessa"/>
+        <a:font script="Syre" typeface="Estrangelo Edessa"/>
+        <a:font script="Sora" typeface="Nirmala UI"/>
+        <a:font script="Tale" typeface="Microsoft Tai Le"/>
+        <a:font script="Talu" typeface="Microsoft New Tai Lue"/>
+        <a:font script="Tfng" typeface="Ebrima"/>
+      </a:minorFont>
+    </a:fontScheme>
+    <a:fmtScheme name="Office">
+      <a:fillStyleLst>
+        <a:solidFill>
+          <a:schemeClr val="phClr"/>
+        </a:solidFill>
+        <a:gradFill rotWithShape="1">
+          <a:gsLst>
+            <a:gs pos="0">
+              <a:schemeClr val="phClr">
+                <a:lumMod val="110000"/>
+                <a:satMod val="105000"/>
+                <a:tint val="67000"/>
+              </a:schemeClr>
+            </a:gs>
+            <a:gs pos="50000">
+              <a:schemeClr val="phClr">
+                <a:lumMod val="105000"/>
+                <a:satMod val="103000"/>
+                <a:tint val="73000"/>
+              </a:schemeClr>
+            </a:gs>
+            <a:gs pos="100000">
+              <a:schemeClr val="phClr">
+                <a:lumMod val="105000"/>
+                <a:satMod val="109000"/>
+                <a:tint val="81000"/>
+              </a:schemeClr>
+            </a:gs>
+          </a:gsLst>
+          <a:lin ang="5400000" scaled="0"/>
+        </a:gradFill>
+        <a:gradFill rotWithShape="1">
+          <a:gsLst>
+            <a:gs pos="0">
+              <a:schemeClr val="phClr">
+                <a:satMod val="103000"/>
+                <a:lumMod val="102000"/>
+                <a:tint val="94000"/>
+              </a:schemeClr>
+            </a:gs>
+            <a:gs pos="50000">
+              <a:schemeClr val="phClr">
+                <a:satMod val="110000"/>
+                <a:lumMod val="100000"/>
+                <a:shade val="100000"/>
+              </a:schemeClr>
+            </a:gs>
+            <a:gs pos="100000">
+              <a:schemeClr val="phClr">
+                <a:lumMod val="99000"/>
+                <a:satMod val="120000"/>
+                <a:shade val="78000"/>
+              </a:schemeClr>
+            </a:gs>
+          </a:gsLst>
+          <a:lin ang="5400000" scaled="0"/>
+        </a:gradFill>
+      </a:fillStyleLst>
+      <a:lnStyleLst>
+        <a:ln w="6350" cap="flat" cmpd="sng" algn="ctr">
+          <a:solidFill>
+            <a:schemeClr val="phClr"/>
+          </a:solidFill>
+          <a:prstDash val="solid"/>
+          <a:miter lim="800000"/>
+        </a:ln>
+        <a:ln w="12700" cap="flat" cmpd="sng" algn="ctr">
+          <a:solidFill>
+            <a:schemeClr val="phClr"/>
+          </a:solidFill>
+          <a:prstDash val="solid"/>
+          <a:miter lim="800000"/>
+        </a:ln>
+        <a:ln w="19050" cap="flat" cmpd="sng" algn="ctr">
+          <a:solidFill>
+            <a:schemeClr val="phClr"/>
+          </a:solidFill>
+          <a:prstDash val="solid"/>
+          <a:miter lim="800000"/>
+        </a:ln>
+      </a:lnStyleLst>
+      <a:effectStyleLst>
+        <a:effectStyle>
+          <a:effectLst/>
+        </a:effectStyle>
+        <a:effectStyle>
+          <a:effectLst/>
+        </a:effectStyle>
+        <a:effectStyle>
+          <a:effectLst>
+            <a:outerShdw blurRad="57150" dist="19050" dir="5400000" algn="ctr" rotWithShape="0">
+              <a:srgbClr val="000000">
+                <a:alpha val="63000"/>
+              </a:srgbClr>
+            </a:outerShdw>
+          </a:effectLst>
+        </a:effectStyle>
+      </a:effectStyleLst>
+      <a:bgFillStyleLst>
+        <a:solidFill>
+          <a:schemeClr val="phClr"/>
+        </a:solidFill>
+        <a:solidFill>
+          <a:schemeClr val="phClr">
+            <a:tint val="95000"/>
+            <a:satMod val="170000"/>
+          </a:schemeClr>
+        </a:solidFill>
+        <a:gradFill rotWithShape="1">
+          <a:gsLst>
+            <a:gs pos="0">
+              <a:schemeClr val="phClr">
+                <a:tint val="93000"/>
+                <a:satMod val="150000"/>
+                <a:shade val="98000"/>
+                <a:lumMod val="102000"/>
+              </a:schemeClr>
+            </a:gs>
+            <a:gs pos="50000">
+              <a:schemeClr val="phClr">
+                <a:tint val="98000"/>
+                <a:satMod val="130000"/>
+                <a:shade val="90000"/>
+                <a:lumMod val="103000"/>
+              </a:schemeClr>
+            </a:gs>
+            <a:gs pos="100000">
+              <a:schemeClr val="phClr">
+                <a:shade val="63000"/>
+                <a:satMod val="120000"/>
+              </a:schemeClr>
+            </a:gs>
+          </a:gsLst>
+          <a:lin ang="5400000" scaled="0"/>
+        </a:gradFill>
+      </a:bgFillStyleLst>
+    </a:fmtScheme>
+  </a:themeElements>
+  <a:objectDefaults/>
+  <a:extraClrSchemeLst/>
+  <a:extLst>
+    <a:ext uri="{05A4C25C-085E-4340-85A3-A5531E510DB2}">
+      <thm15:themeFamily xmlns:thm15="http://schemas.microsoft.com/office/thememl/2012/main" name="Office Theme" id="{62F939B6-93AF-4DB8-9C6B-D6C7DFDC589F}" vid="{4A3C46E8-61CC-4603-A589-7422A47A8E4A}"/>
+    </a:ext>
+  </a:extLst>
+</a:theme>
 </file>
</xml_diff>